<commit_message>
style(presentacion): bordes negros, texto unificado en negro, sin rayas y formulas en LaTeX
</commit_message>
<xml_diff>
--- a/presentacion/presentacion_materiales_uriel.pptx
+++ b/presentacion/presentacion_materiales_uriel.pptx
@@ -584,22 +584,27 @@
           </a:p>
           <a:p>
             <a:r>
-              <a:t>Definimos el problema físico: las propiedades de transporte revelan directamente la estructura de bandas.</a:t>
-            </a:r>
-          </a:p>
-          <a:p>
-            <a:r>
-              <a:t>- Metales: bandas solapadas, electrones libres, alfa positivo por choques con fonones.</a:t>
-            </a:r>
-          </a:p>
-          <a:p>
-            <a:r>
-              <a:t>- Semiconductores: bandgap moderado (~1 eV), alfa fuertemente negativo por activación térmica según Boltzmann.</a:t>
-            </a:r>
-          </a:p>
-          <a:p>
-            <a:r>
-              <a:t>- Aislantes: bandgap colosal (&gt; 5 eV), sin portadores libres a 300 K, alfa nulo y resistividad extrema.</a:t>
+              <a:t>Definimos el problema físico a partir de las ecuaciones de transporte en LaTeX:</a:t>
+            </a:r>
+          </a:p>
+          <a:p>
+            <a:r>
+              <a:t>- La variación térmica de la resistividad rho(T) y su derivada térmica alfa.</a:t>
+            </a:r>
+          </a:p>
+          <a:p>
+            <a:r>
+              <a:t>- Metales: bandas solapadas, electrones libres, alfa positivo por choques con fonones de la red.</a:t>
+            </a:r>
+          </a:p>
+          <a:p>
+            <a:r>
+              <a:t>- Semiconductores: bandgap moderado, alfa negativo por activación térmica exponencial según Boltzmann.</a:t>
+            </a:r>
+          </a:p>
+          <a:p>
+            <a:r>
+              <a:t>- Aislantes: bandgap colosal (&gt; 5 eV), sin portadores libres a 300 K, alfa nulo y resistividad gigantesca.</a:t>
             </a:r>
           </a:p>
         </p:txBody>
@@ -834,7 +839,7 @@
           </a:p>
           <a:p>
             <a:r>
-              <a:t>En metodología: solo las fórmulas esenciales.</a:t>
+              <a:t>En metodología: fórmulas en LaTeX claras y limpias.</a:t>
             </a:r>
           </a:p>
           <a:p>
@@ -1034,12 +1039,12 @@
           </a:p>
           <a:p>
             <a:r>
-              <a:t>- En semiconductores, los 10 materiales tecnológicos puros (silicio, germanio, arseniuro de galio) forman el cluster 2. Los dos restantes son semimetales cuyo transporte a 300 K es prácticamente metálico.</a:t>
-            </a:r>
-          </a:p>
-          <a:p>
-            <a:r>
-              <a:t>Y como métrica matemática no supervisada, el Silhouette Score arroja 0.7858, confirmando la solidez del agrupamiento.</a:t>
+              <a:t>- En semiconductores, los 10 materiales tecnológicos puros forman el cluster 2. Los dos restantes son semimetales cuyo transporte a 300 K es prácticamente metálico.</a:t>
+            </a:r>
+          </a:p>
+          <a:p>
+            <a:r>
+              <a:t>Y como métrica matemática complementaria, la fórmula en LaTeX de Silhouette Score arroja 0.7858.</a:t>
             </a:r>
           </a:p>
         </p:txBody>
@@ -4155,11 +4160,11 @@
             <a:avLst/>
           </a:prstGeom>
           <a:solidFill>
-            <a:srgbClr val="F8FAFC"/>
+            <a:srgbClr val="FFFFFF"/>
           </a:solidFill>
-          <a:ln w="13970">
+          <a:ln w="19050">
             <a:solidFill>
-              <a:srgbClr val="059669"/>
+              <a:srgbClr val="000000"/>
             </a:solidFill>
           </a:ln>
         </p:spPr>
@@ -4210,7 +4215,7 @@
             <a:pPr>
               <a:defRPr sz="1300" b="1">
                 <a:solidFill>
-                  <a:srgbClr val="059669"/>
+                  <a:srgbClr val="000000"/>
                 </a:solidFill>
               </a:defRPr>
             </a:pPr>
@@ -4245,7 +4250,7 @@
             <a:pPr>
               <a:defRPr sz="3600" b="1">
                 <a:solidFill>
-                  <a:srgbClr val="0F172A"/>
+                  <a:srgbClr val="000000"/>
                 </a:solidFill>
               </a:defRPr>
             </a:pPr>
@@ -4280,7 +4285,7 @@
             <a:pPr>
               <a:defRPr sz="1700">
                 <a:solidFill>
-                  <a:srgbClr val="334155"/>
+                  <a:srgbClr val="000000"/>
                 </a:solidFill>
               </a:defRPr>
             </a:pPr>
@@ -4315,7 +4320,7 @@
             <a:pPr>
               <a:defRPr sz="1600" b="1">
                 <a:solidFill>
-                  <a:srgbClr val="0F172A"/>
+                  <a:srgbClr val="000000"/>
                 </a:solidFill>
               </a:defRPr>
             </a:pPr>
@@ -4327,7 +4332,7 @@
             <a:pPr>
               <a:defRPr sz="1400">
                 <a:solidFill>
-                  <a:srgbClr val="64748B"/>
+                  <a:srgbClr val="000000"/>
                 </a:solidFill>
               </a:defRPr>
             </a:pPr>
@@ -4363,7 +4368,7 @@
         </p:nvSpPr>
         <p:spPr>
           <a:xfrm>
-            <a:off x="731520" y="320040"/>
+            <a:off x="731520" y="365760"/>
             <a:ext cx="10698480" cy="320040"/>
           </a:xfrm>
           <a:prstGeom prst="rect">
@@ -4380,12 +4385,12 @@
             <a:pPr>
               <a:defRPr sz="1050" b="1">
                 <a:solidFill>
-                  <a:srgbClr val="059669"/>
+                  <a:srgbClr val="000000"/>
                 </a:solidFill>
               </a:defRPr>
             </a:pPr>
             <a:r>
-              <a:t>CPIA · CLUSTERING EN FÍSICA</a:t>
+              <a:t>CPIA · APRENDIZAJE NO SUPERVISADO</a:t>
             </a:r>
           </a:p>
         </p:txBody>
@@ -4398,7 +4403,7 @@
         </p:nvSpPr>
         <p:spPr>
           <a:xfrm>
-            <a:off x="731520" y="621792"/>
+            <a:off x="731520" y="685800"/>
             <a:ext cx="10698480" cy="640080"/>
           </a:xfrm>
           <a:prstGeom prst="rect">
@@ -4413,9 +4418,9 @@
           <a:lstStyle/>
           <a:p>
             <a:pPr>
-              <a:defRPr sz="2200" b="1">
-                <a:solidFill>
-                  <a:srgbClr val="0F172A"/>
+              <a:defRPr sz="2300" b="1">
+                <a:solidFill>
+                  <a:srgbClr val="000000"/>
                 </a:solidFill>
               </a:defRPr>
             </a:pPr>
@@ -4427,24 +4432,24 @@
       </p:sp>
       <p:sp>
         <p:nvSpPr>
-          <p:cNvPr id="4" name="Rectangle 3"/>
+          <p:cNvPr id="4" name="Rounded Rectangle 3"/>
           <p:cNvSpPr/>
           <p:nvPr/>
         </p:nvSpPr>
         <p:spPr>
           <a:xfrm>
-            <a:off x="731520" y="1298448"/>
-            <a:ext cx="10728655" cy="18288"/>
-          </a:xfrm>
-          <a:prstGeom prst="rect">
+            <a:off x="731520" y="1417320"/>
+            <a:ext cx="10728655" cy="1234440"/>
+          </a:xfrm>
+          <a:prstGeom prst="roundRect">
             <a:avLst/>
           </a:prstGeom>
           <a:solidFill>
-            <a:srgbClr val="CBD5E1"/>
+            <a:srgbClr val="FFFFFF"/>
           </a:solidFill>
-          <a:ln>
+          <a:ln w="19050">
             <a:solidFill>
-              <a:srgbClr val="CBD5E1"/>
+              <a:srgbClr val="000000"/>
             </a:solidFill>
           </a:ln>
         </p:spPr>
@@ -4472,59 +4477,14 @@
       </p:sp>
       <p:sp>
         <p:nvSpPr>
-          <p:cNvPr id="5" name="Rounded Rectangle 4"/>
-          <p:cNvSpPr/>
-          <p:nvPr/>
-        </p:nvSpPr>
-        <p:spPr>
-          <a:xfrm>
-            <a:off x="731520" y="1463040"/>
-            <a:ext cx="10728655" cy="1188720"/>
-          </a:xfrm>
-          <a:prstGeom prst="roundRect">
-            <a:avLst/>
-          </a:prstGeom>
-          <a:solidFill>
-            <a:srgbClr val="F8FAFC"/>
-          </a:solidFill>
-          <a:ln w="13970">
-            <a:solidFill>
-              <a:srgbClr val="2563EB"/>
-            </a:solidFill>
-          </a:ln>
-        </p:spPr>
-        <p:style>
-          <a:lnRef idx="1">
-            <a:schemeClr val="accent1"/>
-          </a:lnRef>
-          <a:fillRef idx="3">
-            <a:schemeClr val="accent1"/>
-          </a:fillRef>
-          <a:effectRef idx="2">
-            <a:schemeClr val="accent1"/>
-          </a:effectRef>
-          <a:fontRef idx="minor">
-            <a:schemeClr val="lt1"/>
-          </a:fontRef>
-        </p:style>
-        <p:txBody>
-          <a:bodyPr rtlCol="0" anchor="ctr"/>
-          <a:lstStyle/>
-          <a:p>
-            <a:pPr algn="ctr"/>
-          </a:p>
-        </p:txBody>
-      </p:sp>
-      <p:sp>
-        <p:nvSpPr>
-          <p:cNvPr id="6" name="TextBox 5"/>
+          <p:cNvPr id="5" name="TextBox 4"/>
           <p:cNvSpPr txBox="1"/>
           <p:nvPr/>
         </p:nvSpPr>
         <p:spPr>
           <a:xfrm>
-            <a:off x="914400" y="1508760"/>
-            <a:ext cx="10332720" cy="1097280"/>
+            <a:off x="914400" y="1463040"/>
+            <a:ext cx="10332720" cy="320040"/>
           </a:xfrm>
           <a:prstGeom prst="rect">
             <a:avLst/>
@@ -4532,7 +4492,7 @@
           <a:noFill/>
         </p:spPr>
         <p:txBody>
-          <a:bodyPr wrap="square">
+          <a:bodyPr wrap="none">
             <a:spAutoFit/>
           </a:bodyPr>
           <a:lstStyle/>
@@ -4540,7 +4500,7 @@
             <a:pPr>
               <a:defRPr sz="1200" b="1">
                 <a:solidFill>
-                  <a:srgbClr val="2563EB"/>
+                  <a:srgbClr val="000000"/>
                 </a:solidFill>
               </a:defRPr>
             </a:pPr>
@@ -4548,23 +4508,32 @@
               <a:t>Ecuaciones Macroscópicas de Transporte Eléctrico:</a:t>
             </a:r>
           </a:p>
-          <a:p>
-            <a:pPr>
-              <a:spcBef>
-                <a:spcPts val="400"/>
-              </a:spcBef>
-              <a:defRPr sz="1500" b="1">
-                <a:solidFill>
-                  <a:srgbClr val="0F172A"/>
-                </a:solidFill>
-              </a:defRPr>
-            </a:pPr>
-            <a:r>
-              <a:t>1. Variación térmica:  ρ(T) = ρ₀ · [1 + α·(T - T₀)]       2. Coeficiente térmico:  α = (1 / ρ₀) · (dρ / dT)₃₀₀K</a:t>
-            </a:r>
-          </a:p>
-        </p:txBody>
-      </p:sp>
+        </p:txBody>
+      </p:sp>
+      <p:pic>
+        <p:nvPicPr>
+          <p:cNvPr id="6" name="Picture 5" descr="formula_transporte.png"/>
+          <p:cNvPicPr>
+            <a:picLocks noChangeAspect="1"/>
+          </p:cNvPicPr>
+          <p:nvPr/>
+        </p:nvPicPr>
+        <p:blipFill>
+          <a:blip r:embed="rId2"/>
+          <a:stretch>
+            <a:fillRect/>
+          </a:stretch>
+        </p:blipFill>
+        <p:spPr>
+          <a:xfrm>
+            <a:off x="1645920" y="1783080"/>
+            <a:ext cx="8869680" cy="1424232"/>
+          </a:xfrm>
+          <a:prstGeom prst="rect">
+            <a:avLst/>
+          </a:prstGeom>
+        </p:spPr>
+      </p:pic>
       <p:pic>
         <p:nvPicPr>
           <p:cNvPr id="7" name="Picture 6" descr="esquema_bandas_materiales.png"/>
@@ -4574,7 +4543,7 @@
           <p:nvPr/>
         </p:nvPicPr>
         <p:blipFill>
-          <a:blip r:embed="rId2"/>
+          <a:blip r:embed="rId3"/>
           <a:stretch>
             <a:fillRect/>
           </a:stretch>
@@ -4615,7 +4584,7 @@
         </p:nvSpPr>
         <p:spPr>
           <a:xfrm>
-            <a:off x="731520" y="320040"/>
+            <a:off x="731520" y="365760"/>
             <a:ext cx="10698480" cy="320040"/>
           </a:xfrm>
           <a:prstGeom prst="rect">
@@ -4632,12 +4601,12 @@
             <a:pPr>
               <a:defRPr sz="1050" b="1">
                 <a:solidFill>
-                  <a:srgbClr val="059669"/>
+                  <a:srgbClr val="000000"/>
                 </a:solidFill>
               </a:defRPr>
             </a:pPr>
             <a:r>
-              <a:t>CPIA · CLUSTERING EN FÍSICA</a:t>
+              <a:t>CPIA · APRENDIZAJE NO SUPERVISADO</a:t>
             </a:r>
           </a:p>
         </p:txBody>
@@ -4650,7 +4619,7 @@
         </p:nvSpPr>
         <p:spPr>
           <a:xfrm>
-            <a:off x="731520" y="621792"/>
+            <a:off x="731520" y="685800"/>
             <a:ext cx="10698480" cy="640080"/>
           </a:xfrm>
           <a:prstGeom prst="rect">
@@ -4665,9 +4634,9 @@
           <a:lstStyle/>
           <a:p>
             <a:pPr>
-              <a:defRPr sz="2200" b="1">
-                <a:solidFill>
-                  <a:srgbClr val="0F172A"/>
+              <a:defRPr sz="2300" b="1">
+                <a:solidFill>
+                  <a:srgbClr val="000000"/>
                 </a:solidFill>
               </a:defRPr>
             </a:pPr>
@@ -4679,24 +4648,24 @@
       </p:sp>
       <p:sp>
         <p:nvSpPr>
-          <p:cNvPr id="4" name="Rectangle 3"/>
+          <p:cNvPr id="4" name="Rounded Rectangle 3"/>
           <p:cNvSpPr/>
           <p:nvPr/>
         </p:nvSpPr>
         <p:spPr>
           <a:xfrm>
-            <a:off x="731520" y="1298448"/>
-            <a:ext cx="10728655" cy="18288"/>
-          </a:xfrm>
-          <a:prstGeom prst="rect">
+            <a:off x="731520" y="1463040"/>
+            <a:ext cx="4206240" cy="4846320"/>
+          </a:xfrm>
+          <a:prstGeom prst="roundRect">
             <a:avLst/>
           </a:prstGeom>
           <a:solidFill>
-            <a:srgbClr val="CBD5E1"/>
+            <a:srgbClr val="FFFFFF"/>
           </a:solidFill>
-          <a:ln>
+          <a:ln w="19050">
             <a:solidFill>
-              <a:srgbClr val="CBD5E1"/>
+              <a:srgbClr val="000000"/>
             </a:solidFill>
           </a:ln>
         </p:spPr>
@@ -4724,59 +4693,14 @@
       </p:sp>
       <p:sp>
         <p:nvSpPr>
-          <p:cNvPr id="5" name="Rounded Rectangle 4"/>
-          <p:cNvSpPr/>
-          <p:nvPr/>
-        </p:nvSpPr>
-        <p:spPr>
-          <a:xfrm>
-            <a:off x="731520" y="1508760"/>
-            <a:ext cx="4023360" cy="4754880"/>
-          </a:xfrm>
-          <a:prstGeom prst="roundRect">
-            <a:avLst/>
-          </a:prstGeom>
-          <a:solidFill>
-            <a:srgbClr val="F8FAFC"/>
-          </a:solidFill>
-          <a:ln w="13970">
-            <a:solidFill>
-              <a:srgbClr val="CBD5E1"/>
-            </a:solidFill>
-          </a:ln>
-        </p:spPr>
-        <p:style>
-          <a:lnRef idx="1">
-            <a:schemeClr val="accent1"/>
-          </a:lnRef>
-          <a:fillRef idx="3">
-            <a:schemeClr val="accent1"/>
-          </a:fillRef>
-          <a:effectRef idx="2">
-            <a:schemeClr val="accent1"/>
-          </a:effectRef>
-          <a:fontRef idx="minor">
-            <a:schemeClr val="lt1"/>
-          </a:fontRef>
-        </p:style>
-        <p:txBody>
-          <a:bodyPr rtlCol="0" anchor="ctr"/>
-          <a:lstStyle/>
-          <a:p>
-            <a:pPr algn="ctr"/>
-          </a:p>
-        </p:txBody>
-      </p:sp>
-      <p:sp>
-        <p:nvSpPr>
-          <p:cNvPr id="6" name="TextBox 5"/>
+          <p:cNvPr id="5" name="TextBox 4"/>
           <p:cNvSpPr txBox="1"/>
           <p:nvPr/>
         </p:nvSpPr>
         <p:spPr>
           <a:xfrm>
-            <a:off x="914400" y="1645920"/>
-            <a:ext cx="3657600" cy="4389120"/>
+            <a:off x="914400" y="1600200"/>
+            <a:ext cx="3840480" cy="4572000"/>
           </a:xfrm>
           <a:prstGeom prst="rect">
             <a:avLst/>
@@ -4792,94 +4716,19 @@
             <a:pPr>
               <a:defRPr sz="1700" b="1">
                 <a:solidFill>
-                  <a:srgbClr val="0F172A"/>
+                  <a:srgbClr val="000000"/>
                 </a:solidFill>
               </a:defRPr>
             </a:pPr>
             <a:r>
               <a:t>¿Cómo clasificar sin etiquetas?</a:t>
-            </a:r>
-          </a:p>
-          <a:p>
-            <a:pPr>
-              <a:spcAft>
-                <a:spcPts val="800"/>
-              </a:spcAft>
-              <a:defRPr sz="1200">
-                <a:solidFill>
-                  <a:srgbClr val="1E293B"/>
-                </a:solidFill>
-              </a:defRPr>
-            </a:pPr>
-            <a:r>
-              <a:t>• 57 Materiales reales: Metales puros, aleaciones, semiconductores y aislantes.</a:t>
-            </a:r>
-          </a:p>
-          <a:p>
-            <a:pPr>
-              <a:spcAft>
-                <a:spcPts val="800"/>
-              </a:spcAft>
-              <a:defRPr sz="1200">
-                <a:solidFill>
-                  <a:srgbClr val="1E293B"/>
-                </a:solidFill>
-              </a:defRPr>
-            </a:pPr>
-            <a:r>
-              <a:t>• 30 órdenes de magnitud: De metales (~10⁻⁸ Ω·m) a teflón (&gt; 10²² Ω·m).</a:t>
-            </a:r>
-          </a:p>
-          <a:p>
-            <a:pPr>
-              <a:spcAft>
-                <a:spcPts val="800"/>
-              </a:spcAft>
-              <a:defRPr sz="1200">
-                <a:solidFill>
-                  <a:srgbClr val="1E293B"/>
-                </a:solidFill>
-              </a:defRPr>
-            </a:pPr>
-            <a:r>
-              <a:t>• Compresión logarítmica: x₁ = log₁₀(ρ₃₀₀K) evita el colapso numérico.</a:t>
-            </a:r>
-          </a:p>
-          <a:p>
-            <a:pPr>
-              <a:spcAft>
-                <a:spcPts val="800"/>
-              </a:spcAft>
-              <a:defRPr sz="1200">
-                <a:solidFill>
-                  <a:srgbClr val="1E293B"/>
-                </a:solidFill>
-              </a:defRPr>
-            </a:pPr>
-            <a:r>
-              <a:t>• Firma cuántica: x₂ = α (diferencia el origen microscópico).</a:t>
-            </a:r>
-          </a:p>
-          <a:p>
-            <a:pPr>
-              <a:spcAft>
-                <a:spcPts val="800"/>
-              </a:spcAft>
-              <a:defRPr sz="1200">
-                <a:solidFill>
-                  <a:srgbClr val="1E293B"/>
-                </a:solidFill>
-              </a:defRPr>
-            </a:pPr>
-            <a:r>
-              <a:t>• Objetivo no supervisado: Identificar las fases de forma autónoma por densidad.</a:t>
             </a:r>
           </a:p>
         </p:txBody>
       </p:sp>
       <p:pic>
         <p:nvPicPr>
-          <p:cNvPr id="7" name="Picture 6" descr="distribucion_escala_rho.png"/>
+          <p:cNvPr id="6" name="Picture 5" descr="formula_coordenadas.png"/>
           <p:cNvPicPr>
             <a:picLocks noChangeAspect="1"/>
           </p:cNvPicPr>
@@ -4893,8 +4742,130 @@
         </p:blipFill>
         <p:spPr>
           <a:xfrm>
-            <a:off x="4937760" y="1783080"/>
-            <a:ext cx="6492240" cy="2426393"/>
+            <a:off x="914400" y="2103120"/>
+            <a:ext cx="3749039" cy="670931"/>
+          </a:xfrm>
+          <a:prstGeom prst="rect">
+            <a:avLst/>
+          </a:prstGeom>
+        </p:spPr>
+      </p:pic>
+      <p:sp>
+        <p:nvSpPr>
+          <p:cNvPr id="7" name="TextBox 6"/>
+          <p:cNvSpPr txBox="1"/>
+          <p:nvPr/>
+        </p:nvSpPr>
+        <p:spPr>
+          <a:xfrm>
+            <a:off x="914400" y="2834640"/>
+            <a:ext cx="3840480" cy="3383280"/>
+          </a:xfrm>
+          <a:prstGeom prst="rect">
+            <a:avLst/>
+          </a:prstGeom>
+          <a:noFill/>
+        </p:spPr>
+        <p:txBody>
+          <a:bodyPr wrap="square">
+            <a:spAutoFit/>
+          </a:bodyPr>
+          <a:lstStyle/>
+          <a:p>
+            <a:pPr>
+              <a:spcAft>
+                <a:spcPts val="700"/>
+              </a:spcAft>
+              <a:defRPr sz="1150">
+                <a:solidFill>
+                  <a:srgbClr val="000000"/>
+                </a:solidFill>
+              </a:defRPr>
+            </a:pPr>
+            <a:r>
+              <a:t>• 57 Materiales reales: Metales puros, aleaciones, semiconductores y dieléctricos.</a:t>
+            </a:r>
+          </a:p>
+          <a:p>
+            <a:pPr>
+              <a:spcAft>
+                <a:spcPts val="700"/>
+              </a:spcAft>
+              <a:defRPr sz="1150">
+                <a:solidFill>
+                  <a:srgbClr val="000000"/>
+                </a:solidFill>
+              </a:defRPr>
+            </a:pPr>
+            <a:r>
+              <a:t>• 30 órdenes de magnitud: De conductores (~10⁻⁸ Ω·m) a teflón (&gt; 10²² Ω·m).</a:t>
+            </a:r>
+          </a:p>
+          <a:p>
+            <a:pPr>
+              <a:spcAft>
+                <a:spcPts val="700"/>
+              </a:spcAft>
+              <a:defRPr sz="1150">
+                <a:solidFill>
+                  <a:srgbClr val="000000"/>
+                </a:solidFill>
+              </a:defRPr>
+            </a:pPr>
+            <a:r>
+              <a:t>• Compresión logarítmica: Evita el colapso numérico en el origen.</a:t>
+            </a:r>
+          </a:p>
+          <a:p>
+            <a:pPr>
+              <a:spcAft>
+                <a:spcPts val="700"/>
+              </a:spcAft>
+              <a:defRPr sz="1150">
+                <a:solidFill>
+                  <a:srgbClr val="000000"/>
+                </a:solidFill>
+              </a:defRPr>
+            </a:pPr>
+            <a:r>
+              <a:t>• Firma cuántica: α delata el origen microscópico del transporte.</a:t>
+            </a:r>
+          </a:p>
+          <a:p>
+            <a:pPr>
+              <a:spcAft>
+                <a:spcPts val="700"/>
+              </a:spcAft>
+              <a:defRPr sz="1150">
+                <a:solidFill>
+                  <a:srgbClr val="000000"/>
+                </a:solidFill>
+              </a:defRPr>
+            </a:pPr>
+            <a:r>
+              <a:t>• Objetivo no supervisado: Descubrir las clases automáticamente por densidad.</a:t>
+            </a:r>
+          </a:p>
+        </p:txBody>
+      </p:sp>
+      <p:pic>
+        <p:nvPicPr>
+          <p:cNvPr id="8" name="Picture 7" descr="distribucion_escala_rho.png"/>
+          <p:cNvPicPr>
+            <a:picLocks noChangeAspect="1"/>
+          </p:cNvPicPr>
+          <p:nvPr/>
+        </p:nvPicPr>
+        <p:blipFill>
+          <a:blip r:embed="rId3"/>
+          <a:stretch>
+            <a:fillRect/>
+          </a:stretch>
+        </p:blipFill>
+        <p:spPr>
+          <a:xfrm>
+            <a:off x="5120640" y="1737360"/>
+            <a:ext cx="6309360" cy="2358044"/>
           </a:xfrm>
           <a:prstGeom prst="rect">
             <a:avLst/>
@@ -4927,7 +4898,7 @@
         </p:nvSpPr>
         <p:spPr>
           <a:xfrm>
-            <a:off x="731520" y="320040"/>
+            <a:off x="731520" y="365760"/>
             <a:ext cx="10698480" cy="320040"/>
           </a:xfrm>
           <a:prstGeom prst="rect">
@@ -4944,12 +4915,12 @@
             <a:pPr>
               <a:defRPr sz="1050" b="1">
                 <a:solidFill>
-                  <a:srgbClr val="059669"/>
+                  <a:srgbClr val="000000"/>
                 </a:solidFill>
               </a:defRPr>
             </a:pPr>
             <a:r>
-              <a:t>CPIA · CLUSTERING EN FÍSICA</a:t>
+              <a:t>CPIA · APRENDIZAJE NO SUPERVISADO</a:t>
             </a:r>
           </a:p>
         </p:txBody>
@@ -4962,7 +4933,7 @@
         </p:nvSpPr>
         <p:spPr>
           <a:xfrm>
-            <a:off x="731520" y="621792"/>
+            <a:off x="731520" y="685800"/>
             <a:ext cx="10698480" cy="640080"/>
           </a:xfrm>
           <a:prstGeom prst="rect">
@@ -4977,9 +4948,9 @@
           <a:lstStyle/>
           <a:p>
             <a:pPr>
-              <a:defRPr sz="2200" b="1">
-                <a:solidFill>
-                  <a:srgbClr val="0F172A"/>
+              <a:defRPr sz="2300" b="1">
+                <a:solidFill>
+                  <a:srgbClr val="000000"/>
                 </a:solidFill>
               </a:defRPr>
             </a:pPr>
@@ -4991,24 +4962,24 @@
       </p:sp>
       <p:sp>
         <p:nvSpPr>
-          <p:cNvPr id="4" name="Rectangle 3"/>
+          <p:cNvPr id="4" name="Rounded Rectangle 3"/>
           <p:cNvSpPr/>
           <p:nvPr/>
         </p:nvSpPr>
         <p:spPr>
           <a:xfrm>
-            <a:off x="731520" y="1298448"/>
-            <a:ext cx="10728655" cy="18288"/>
-          </a:xfrm>
-          <a:prstGeom prst="rect">
+            <a:off x="731520" y="1463040"/>
+            <a:ext cx="4389120" cy="4846320"/>
+          </a:xfrm>
+          <a:prstGeom prst="roundRect">
             <a:avLst/>
           </a:prstGeom>
           <a:solidFill>
-            <a:srgbClr val="CBD5E1"/>
+            <a:srgbClr val="FFFFFF"/>
           </a:solidFill>
-          <a:ln>
+          <a:ln w="19050">
             <a:solidFill>
-              <a:srgbClr val="CBD5E1"/>
+              <a:srgbClr val="000000"/>
             </a:solidFill>
           </a:ln>
         </p:spPr>
@@ -5036,59 +5007,14 @@
       </p:sp>
       <p:sp>
         <p:nvSpPr>
-          <p:cNvPr id="5" name="Rounded Rectangle 4"/>
-          <p:cNvSpPr/>
-          <p:nvPr/>
-        </p:nvSpPr>
-        <p:spPr>
-          <a:xfrm>
-            <a:off x="731520" y="1508760"/>
-            <a:ext cx="4389120" cy="4754880"/>
-          </a:xfrm>
-          <a:prstGeom prst="roundRect">
-            <a:avLst/>
-          </a:prstGeom>
-          <a:solidFill>
-            <a:srgbClr val="F8FAFC"/>
-          </a:solidFill>
-          <a:ln w="13970">
-            <a:solidFill>
-              <a:srgbClr val="CBD5E1"/>
-            </a:solidFill>
-          </a:ln>
-        </p:spPr>
-        <p:style>
-          <a:lnRef idx="1">
-            <a:schemeClr val="accent1"/>
-          </a:lnRef>
-          <a:fillRef idx="3">
-            <a:schemeClr val="accent1"/>
-          </a:fillRef>
-          <a:effectRef idx="2">
-            <a:schemeClr val="accent1"/>
-          </a:effectRef>
-          <a:fontRef idx="minor">
-            <a:schemeClr val="lt1"/>
-          </a:fontRef>
-        </p:style>
-        <p:txBody>
-          <a:bodyPr rtlCol="0" anchor="ctr"/>
-          <a:lstStyle/>
-          <a:p>
-            <a:pPr algn="ctr"/>
-          </a:p>
-        </p:txBody>
-      </p:sp>
-      <p:sp>
-        <p:nvSpPr>
-          <p:cNvPr id="6" name="TextBox 5"/>
+          <p:cNvPr id="5" name="TextBox 4"/>
           <p:cNvSpPr txBox="1"/>
           <p:nvPr/>
         </p:nvSpPr>
         <p:spPr>
           <a:xfrm>
-            <a:off x="914400" y="1645920"/>
-            <a:ext cx="4023360" cy="4389120"/>
+            <a:off x="914400" y="1600200"/>
+            <a:ext cx="4023360" cy="4572000"/>
           </a:xfrm>
           <a:prstGeom prst="rect">
             <a:avLst/>
@@ -5104,12 +5030,12 @@
             <a:pPr>
               <a:defRPr sz="1500" b="1">
                 <a:solidFill>
-                  <a:srgbClr val="DC2626"/>
+                  <a:srgbClr val="000000"/>
                 </a:solidFill>
               </a:defRPr>
             </a:pPr>
             <a:r>
-              <a:t>K-Means (Inadecuado aquí)</a:t>
+              <a:t>K-Means (Inadecuado en este dominio)</a:t>
             </a:r>
           </a:p>
           <a:p>
@@ -5119,7 +5045,7 @@
               </a:spcAft>
               <a:defRPr sz="1100">
                 <a:solidFill>
-                  <a:srgbClr val="1E293B"/>
+                  <a:srgbClr val="000000"/>
                 </a:solidFill>
               </a:defRPr>
             </a:pPr>
@@ -5134,7 +5060,7 @@
               </a:spcAft>
               <a:defRPr sz="1100">
                 <a:solidFill>
-                  <a:srgbClr val="1E293B"/>
+                  <a:srgbClr val="000000"/>
                 </a:solidFill>
               </a:defRPr>
             </a:pPr>
@@ -5149,12 +5075,12 @@
               </a:spcAft>
               <a:defRPr sz="1100">
                 <a:solidFill>
-                  <a:srgbClr val="1E293B"/>
+                  <a:srgbClr val="000000"/>
                 </a:solidFill>
               </a:defRPr>
             </a:pPr>
             <a:r>
-              <a:t>✖  Exige fijar 'k' a priori de forma arbitraria.</a:t>
+              <a:t>✖  Exige prefijar 'k' a priori de forma arbitraria.</a:t>
             </a:r>
           </a:p>
           <a:p>
@@ -5164,7 +5090,7 @@
               </a:spcAft>
               <a:defRPr sz="1100">
                 <a:solidFill>
-                  <a:srgbClr val="1E293B"/>
+                  <a:srgbClr val="000000"/>
                 </a:solidFill>
               </a:defRPr>
             </a:pPr>
@@ -5177,7 +5103,7 @@
             <a:pPr>
               <a:defRPr sz="1500" b="1">
                 <a:solidFill>
-                  <a:srgbClr val="059669"/>
+                  <a:srgbClr val="000000"/>
                 </a:solidFill>
               </a:defRPr>
             </a:pPr>
@@ -5192,7 +5118,7 @@
               </a:spcAft>
               <a:defRPr sz="1100">
                 <a:solidFill>
-                  <a:srgbClr val="1E293B"/>
+                  <a:srgbClr val="000000"/>
                 </a:solidFill>
               </a:defRPr>
             </a:pPr>
@@ -5207,7 +5133,7 @@
               </a:spcAft>
               <a:defRPr sz="1100">
                 <a:solidFill>
-                  <a:srgbClr val="1E293B"/>
+                  <a:srgbClr val="000000"/>
                 </a:solidFill>
               </a:defRPr>
             </a:pPr>
@@ -5222,7 +5148,7 @@
               </a:spcAft>
               <a:defRPr sz="1100">
                 <a:solidFill>
-                  <a:srgbClr val="1E293B"/>
+                  <a:srgbClr val="000000"/>
                 </a:solidFill>
               </a:defRPr>
             </a:pPr>
@@ -5237,7 +5163,7 @@
               </a:spcAft>
               <a:defRPr sz="1100">
                 <a:solidFill>
-                  <a:srgbClr val="1E293B"/>
+                  <a:srgbClr val="000000"/>
                 </a:solidFill>
               </a:defRPr>
             </a:pPr>
@@ -5249,7 +5175,7 @@
       </p:sp>
       <p:pic>
         <p:nvPicPr>
-          <p:cNvPr id="7" name="Picture 6" descr="comparativa_kmeans_dbscan.png"/>
+          <p:cNvPr id="6" name="Picture 5" descr="comparativa_kmeans_dbscan.png"/>
           <p:cNvPicPr>
             <a:picLocks noChangeAspect="1"/>
           </p:cNvPicPr>
@@ -5263,7 +5189,7 @@
         </p:blipFill>
         <p:spPr>
           <a:xfrm>
-            <a:off x="5303520" y="1691640"/>
+            <a:off x="5303520" y="1645920"/>
             <a:ext cx="6126480" cy="2537229"/>
           </a:xfrm>
           <a:prstGeom prst="rect">
@@ -5297,7 +5223,7 @@
         </p:nvSpPr>
         <p:spPr>
           <a:xfrm>
-            <a:off x="731520" y="320040"/>
+            <a:off x="731520" y="365760"/>
             <a:ext cx="10698480" cy="320040"/>
           </a:xfrm>
           <a:prstGeom prst="rect">
@@ -5314,12 +5240,12 @@
             <a:pPr>
               <a:defRPr sz="1050" b="1">
                 <a:solidFill>
-                  <a:srgbClr val="059669"/>
+                  <a:srgbClr val="000000"/>
                 </a:solidFill>
               </a:defRPr>
             </a:pPr>
             <a:r>
-              <a:t>CPIA · CLUSTERING EN FÍSICA</a:t>
+              <a:t>CPIA · APRENDIZAJE NO SUPERVISADO</a:t>
             </a:r>
           </a:p>
         </p:txBody>
@@ -5332,7 +5258,7 @@
         </p:nvSpPr>
         <p:spPr>
           <a:xfrm>
-            <a:off x="731520" y="621792"/>
+            <a:off x="731520" y="685800"/>
             <a:ext cx="10698480" cy="640080"/>
           </a:xfrm>
           <a:prstGeom prst="rect">
@@ -5347,9 +5273,9 @@
           <a:lstStyle/>
           <a:p>
             <a:pPr>
-              <a:defRPr sz="2200" b="1">
-                <a:solidFill>
-                  <a:srgbClr val="0F172A"/>
+              <a:defRPr sz="2300" b="1">
+                <a:solidFill>
+                  <a:srgbClr val="000000"/>
                 </a:solidFill>
               </a:defRPr>
             </a:pPr>
@@ -5361,24 +5287,24 @@
       </p:sp>
       <p:sp>
         <p:nvSpPr>
-          <p:cNvPr id="4" name="Rectangle 3"/>
+          <p:cNvPr id="4" name="Rounded Rectangle 3"/>
           <p:cNvSpPr/>
           <p:nvPr/>
         </p:nvSpPr>
         <p:spPr>
           <a:xfrm>
-            <a:off x="731520" y="1298448"/>
-            <a:ext cx="10728655" cy="18288"/>
-          </a:xfrm>
-          <a:prstGeom prst="rect">
+            <a:off x="731520" y="1463040"/>
+            <a:ext cx="3337560" cy="4754880"/>
+          </a:xfrm>
+          <a:prstGeom prst="roundRect">
             <a:avLst/>
           </a:prstGeom>
           <a:solidFill>
-            <a:srgbClr val="CBD5E1"/>
+            <a:srgbClr val="FFFFFF"/>
           </a:solidFill>
-          <a:ln>
+          <a:ln w="19050">
             <a:solidFill>
-              <a:srgbClr val="CBD5E1"/>
+              <a:srgbClr val="000000"/>
             </a:solidFill>
           </a:ln>
         </p:spPr>
@@ -5406,24 +5332,170 @@
       </p:sp>
       <p:sp>
         <p:nvSpPr>
-          <p:cNvPr id="5" name="Rounded Rectangle 4"/>
+          <p:cNvPr id="5" name="TextBox 4"/>
+          <p:cNvSpPr txBox="1"/>
+          <p:nvPr/>
+        </p:nvSpPr>
+        <p:spPr>
+          <a:xfrm>
+            <a:off x="914400" y="1600200"/>
+            <a:ext cx="2971800" cy="914400"/>
+          </a:xfrm>
+          <a:prstGeom prst="rect">
+            <a:avLst/>
+          </a:prstGeom>
+          <a:noFill/>
+        </p:spPr>
+        <p:txBody>
+          <a:bodyPr wrap="none">
+            <a:spAutoFit/>
+          </a:bodyPr>
+          <a:lstStyle/>
+          <a:p>
+            <a:pPr>
+              <a:defRPr sz="1500" b="1">
+                <a:solidFill>
+                  <a:srgbClr val="000000"/>
+                </a:solidFill>
+              </a:defRPr>
+            </a:pPr>
+            <a:r>
+              <a:t>1. Estandarización Z-Score</a:t>
+            </a:r>
+            <a:br/>
+            <a:r>
+              <a:t>(Implementada con NumPy)</a:t>
+            </a:r>
+          </a:p>
+        </p:txBody>
+      </p:sp>
+      <p:pic>
+        <p:nvPicPr>
+          <p:cNvPr id="6" name="Picture 5" descr="formula_zscore.png"/>
+          <p:cNvPicPr>
+            <a:picLocks noChangeAspect="1"/>
+          </p:cNvPicPr>
+          <p:nvPr/>
+        </p:nvPicPr>
+        <p:blipFill>
+          <a:blip r:embed="rId2"/>
+          <a:stretch>
+            <a:fillRect/>
+          </a:stretch>
+        </p:blipFill>
+        <p:spPr>
+          <a:xfrm>
+            <a:off x="868680" y="2331720"/>
+            <a:ext cx="3063240" cy="555864"/>
+          </a:xfrm>
+          <a:prstGeom prst="rect">
+            <a:avLst/>
+          </a:prstGeom>
+        </p:spPr>
+      </p:pic>
+      <p:sp>
+        <p:nvSpPr>
+          <p:cNvPr id="7" name="TextBox 6"/>
+          <p:cNvSpPr txBox="1"/>
+          <p:nvPr/>
+        </p:nvSpPr>
+        <p:spPr>
+          <a:xfrm>
+            <a:off x="914400" y="3703320"/>
+            <a:ext cx="2971800" cy="2468880"/>
+          </a:xfrm>
+          <a:prstGeom prst="rect">
+            <a:avLst/>
+          </a:prstGeom>
+          <a:noFill/>
+        </p:spPr>
+        <p:txBody>
+          <a:bodyPr wrap="square">
+            <a:spAutoFit/>
+          </a:bodyPr>
+          <a:lstStyle/>
+          <a:p>
+            <a:pPr>
+              <a:spcAft>
+                <a:spcPts val="500"/>
+              </a:spcAft>
+              <a:defRPr sz="1100">
+                <a:solidFill>
+                  <a:srgbClr val="000000"/>
+                </a:solidFill>
+              </a:defRPr>
+            </a:pPr>
+            <a:r>
+              <a:t>• μ = Media muestral por columna</a:t>
+            </a:r>
+          </a:p>
+          <a:p>
+            <a:pPr>
+              <a:spcAft>
+                <a:spcPts val="500"/>
+              </a:spcAft>
+              <a:defRPr sz="1100">
+                <a:solidFill>
+                  <a:srgbClr val="000000"/>
+                </a:solidFill>
+              </a:defRPr>
+            </a:pPr>
+            <a:r>
+              <a:t>• σ = Desviación estándar típica</a:t>
+            </a:r>
+          </a:p>
+          <a:p>
+            <a:pPr>
+              <a:spcAft>
+                <a:spcPts val="500"/>
+              </a:spcAft>
+              <a:defRPr sz="1100">
+                <a:solidFill>
+                  <a:srgbClr val="000000"/>
+                </a:solidFill>
+              </a:defRPr>
+            </a:pPr>
+            <a:r>
+              <a:t>• Resultado: Media = 0, Varianza = 1</a:t>
+            </a:r>
+          </a:p>
+          <a:p>
+            <a:pPr>
+              <a:spcAft>
+                <a:spcPts val="500"/>
+              </a:spcAft>
+              <a:defRPr sz="1100">
+                <a:solidFill>
+                  <a:srgbClr val="000000"/>
+                </a:solidFill>
+              </a:defRPr>
+            </a:pPr>
+            <a:r>
+              <a:t>• Imprescindible: equipara el rango de log₁₀ρ (~31) con el de α (~0.08) para la distancia euclídea.</a:t>
+            </a:r>
+          </a:p>
+        </p:txBody>
+      </p:sp>
+      <p:sp>
+        <p:nvSpPr>
+          <p:cNvPr id="8" name="Rounded Rectangle 7"/>
           <p:cNvSpPr/>
           <p:nvPr/>
         </p:nvSpPr>
         <p:spPr>
           <a:xfrm>
-            <a:off x="731520" y="1554480"/>
-            <a:ext cx="3337560" cy="4572000"/>
+            <a:off x="4434840" y="1463040"/>
+            <a:ext cx="3337560" cy="4754880"/>
           </a:xfrm>
           <a:prstGeom prst="roundRect">
             <a:avLst/>
           </a:prstGeom>
           <a:solidFill>
-            <a:srgbClr val="F8FAFC"/>
+            <a:srgbClr val="FFFFFF"/>
           </a:solidFill>
-          <a:ln w="13970">
+          <a:ln w="19050">
             <a:solidFill>
-              <a:srgbClr val="2563EB"/>
+              <a:srgbClr val="000000"/>
             </a:solidFill>
           </a:ln>
         </p:spPr>
@@ -5451,14 +5523,14 @@
       </p:sp>
       <p:sp>
         <p:nvSpPr>
-          <p:cNvPr id="6" name="TextBox 5"/>
+          <p:cNvPr id="9" name="TextBox 8"/>
           <p:cNvSpPr txBox="1"/>
           <p:nvPr/>
         </p:nvSpPr>
         <p:spPr>
           <a:xfrm>
-            <a:off x="914400" y="1737360"/>
-            <a:ext cx="2971800" cy="4114800"/>
+            <a:off x="4617720" y="1600200"/>
+            <a:ext cx="2971800" cy="914400"/>
           </a:xfrm>
           <a:prstGeom prst="rect">
             <a:avLst/>
@@ -5466,122 +5538,200 @@
           <a:noFill/>
         </p:spPr>
         <p:txBody>
+          <a:bodyPr wrap="none">
+            <a:spAutoFit/>
+          </a:bodyPr>
+          <a:lstStyle/>
+          <a:p>
+            <a:pPr>
+              <a:defRPr sz="1500" b="1">
+                <a:solidFill>
+                  <a:srgbClr val="000000"/>
+                </a:solidFill>
+              </a:defRPr>
+            </a:pPr>
+            <a:r>
+              <a:t>2. Criterio de Núcleo</a:t>
+            </a:r>
+            <a:br/>
+            <a:r>
+              <a:t>(DBSCAN Espacial)</a:t>
+            </a:r>
+          </a:p>
+        </p:txBody>
+      </p:sp>
+      <p:pic>
+        <p:nvPicPr>
+          <p:cNvPr id="10" name="Picture 9" descr="formula_nucleo.png"/>
+          <p:cNvPicPr>
+            <a:picLocks noChangeAspect="1"/>
+          </p:cNvPicPr>
+          <p:nvPr/>
+        </p:nvPicPr>
+        <p:blipFill>
+          <a:blip r:embed="rId3"/>
+          <a:stretch>
+            <a:fillRect/>
+          </a:stretch>
+        </p:blipFill>
+        <p:spPr>
+          <a:xfrm>
+            <a:off x="4572000" y="2331720"/>
+            <a:ext cx="3063240" cy="555864"/>
+          </a:xfrm>
+          <a:prstGeom prst="rect">
+            <a:avLst/>
+          </a:prstGeom>
+        </p:spPr>
+      </p:pic>
+      <p:sp>
+        <p:nvSpPr>
+          <p:cNvPr id="11" name="TextBox 10"/>
+          <p:cNvSpPr txBox="1"/>
+          <p:nvPr/>
+        </p:nvSpPr>
+        <p:spPr>
+          <a:xfrm>
+            <a:off x="4617720" y="3703320"/>
+            <a:ext cx="2971800" cy="2468880"/>
+          </a:xfrm>
+          <a:prstGeom prst="rect">
+            <a:avLst/>
+          </a:prstGeom>
+          <a:noFill/>
+        </p:spPr>
+        <p:txBody>
           <a:bodyPr wrap="square">
             <a:spAutoFit/>
           </a:bodyPr>
           <a:lstStyle/>
           <a:p>
             <a:pPr>
-              <a:defRPr sz="1600" b="1">
-                <a:solidFill>
-                  <a:srgbClr val="2563EB"/>
+              <a:spcAft>
+                <a:spcPts val="400"/>
+              </a:spcAft>
+              <a:defRPr sz="1100">
+                <a:solidFill>
+                  <a:srgbClr val="000000"/>
                 </a:solidFill>
               </a:defRPr>
             </a:pPr>
             <a:r>
-              <a:t>1. Estandarización Z-Score</a:t>
-            </a:r>
-            <a:br/>
-            <a:r>
-              <a:t>(Implementada con NumPy)</a:t>
-            </a:r>
-          </a:p>
-          <a:p>
-            <a:br/>
-            <a:pPr algn="ctr">
-              <a:defRPr sz="2200" b="1">
-                <a:solidFill>
-                  <a:srgbClr val="0F172A"/>
-                </a:solidFill>
-              </a:defRPr>
-            </a:pPr>
-            <a:r>
-              <a:t>Z = (X - μ) / σ</a:t>
-            </a:r>
-            <a:br/>
+              <a:t>• d(p, q) = Distancia Euclídea en 2D</a:t>
+            </a:r>
           </a:p>
           <a:p>
             <a:pPr>
               <a:spcAft>
-                <a:spcPts val="600"/>
+                <a:spcPts val="400"/>
               </a:spcAft>
-              <a:defRPr sz="1150">
-                <a:solidFill>
-                  <a:srgbClr val="1E293B"/>
+              <a:defRPr sz="1100">
+                <a:solidFill>
+                  <a:srgbClr val="000000"/>
                 </a:solidFill>
               </a:defRPr>
             </a:pPr>
             <a:r>
-              <a:t>• μ = Media muestral por columna</a:t>
+              <a:t>• Punto Núcleo (Core Point):</a:t>
             </a:r>
           </a:p>
           <a:p>
             <a:pPr>
               <a:spcAft>
-                <a:spcPts val="600"/>
+                <a:spcPts val="400"/>
               </a:spcAft>
-              <a:defRPr sz="1150">
-                <a:solidFill>
-                  <a:srgbClr val="1E293B"/>
+              <a:defRPr sz="1100">
+                <a:solidFill>
+                  <a:srgbClr val="000000"/>
                 </a:solidFill>
               </a:defRPr>
             </a:pPr>
             <a:r>
-              <a:t>• σ = Desviación estándar típica</a:t>
+              <a:t>•    |N_ε(p)| ≥ min_samples</a:t>
             </a:r>
           </a:p>
           <a:p>
             <a:pPr>
               <a:spcAft>
-                <a:spcPts val="600"/>
+                <a:spcPts val="400"/>
               </a:spcAft>
-              <a:defRPr sz="1150">
-                <a:solidFill>
-                  <a:srgbClr val="1E293B"/>
+              <a:defRPr sz="1100">
+                <a:solidFill>
+                  <a:srgbClr val="000000"/>
                 </a:solidFill>
               </a:defRPr>
             </a:pPr>
             <a:r>
-              <a:t>• Resultado: Media = 0, Varianza = 1</a:t>
+              <a:t>• Punto Frontera (Border):</a:t>
             </a:r>
           </a:p>
           <a:p>
             <a:pPr>
               <a:spcAft>
-                <a:spcPts val="600"/>
+                <a:spcPts val="400"/>
               </a:spcAft>
-              <a:defRPr sz="1150">
-                <a:solidFill>
-                  <a:srgbClr val="1E293B"/>
+              <a:defRPr sz="1100">
+                <a:solidFill>
+                  <a:srgbClr val="000000"/>
                 </a:solidFill>
               </a:defRPr>
             </a:pPr>
             <a:r>
-              <a:t>• Imprescindible: equipara el rango de log₁₀ρ (~31) con el rango de α (~0.08) para la distancia euclídea.</a:t>
-            </a:r>
-          </a:p>
-        </p:txBody>
-      </p:sp>
-      <p:sp>
-        <p:nvSpPr>
-          <p:cNvPr id="7" name="Rounded Rectangle 6"/>
+              <a:t>•    Alcanzable desde un núcleo</a:t>
+            </a:r>
+          </a:p>
+          <a:p>
+            <a:pPr>
+              <a:spcAft>
+                <a:spcPts val="400"/>
+              </a:spcAft>
+              <a:defRPr sz="1100">
+                <a:solidFill>
+                  <a:srgbClr val="000000"/>
+                </a:solidFill>
+              </a:defRPr>
+            </a:pPr>
+            <a:r>
+              <a:t>• Ruido (Noise):</a:t>
+            </a:r>
+          </a:p>
+          <a:p>
+            <a:pPr>
+              <a:spcAft>
+                <a:spcPts val="400"/>
+              </a:spcAft>
+              <a:defRPr sz="1100">
+                <a:solidFill>
+                  <a:srgbClr val="000000"/>
+                </a:solidFill>
+              </a:defRPr>
+            </a:pPr>
+            <a:r>
+              <a:t>•    No alcanzable (|N_ε| &lt; min_samples)</a:t>
+            </a:r>
+          </a:p>
+        </p:txBody>
+      </p:sp>
+      <p:sp>
+        <p:nvSpPr>
+          <p:cNvPr id="12" name="Rounded Rectangle 11"/>
           <p:cNvSpPr/>
           <p:nvPr/>
         </p:nvSpPr>
         <p:spPr>
           <a:xfrm>
-            <a:off x="4434840" y="1554480"/>
-            <a:ext cx="3337560" cy="4572000"/>
+            <a:off x="8138160" y="1463040"/>
+            <a:ext cx="3337560" cy="4754880"/>
           </a:xfrm>
           <a:prstGeom prst="roundRect">
             <a:avLst/>
           </a:prstGeom>
           <a:solidFill>
-            <a:srgbClr val="F8FAFC"/>
+            <a:srgbClr val="FFFFFF"/>
           </a:solidFill>
-          <a:ln w="13970">
+          <a:ln w="19050">
             <a:solidFill>
-              <a:srgbClr val="059669"/>
+              <a:srgbClr val="000000"/>
             </a:solidFill>
           </a:ln>
         </p:spPr>
@@ -5609,14 +5759,14 @@
       </p:sp>
       <p:sp>
         <p:nvSpPr>
-          <p:cNvPr id="8" name="TextBox 7"/>
+          <p:cNvPr id="13" name="TextBox 12"/>
           <p:cNvSpPr txBox="1"/>
           <p:nvPr/>
         </p:nvSpPr>
         <p:spPr>
           <a:xfrm>
-            <a:off x="4617720" y="1737360"/>
-            <a:ext cx="2971800" cy="4114800"/>
+            <a:off x="8321040" y="1600200"/>
+            <a:ext cx="2971800" cy="914400"/>
           </a:xfrm>
           <a:prstGeom prst="rect">
             <a:avLst/>
@@ -5624,202 +5774,62 @@
           <a:noFill/>
         </p:spPr>
         <p:txBody>
-          <a:bodyPr wrap="square">
+          <a:bodyPr wrap="none">
             <a:spAutoFit/>
           </a:bodyPr>
           <a:lstStyle/>
           <a:p>
             <a:pPr>
-              <a:defRPr sz="1600" b="1">
-                <a:solidFill>
-                  <a:srgbClr val="059669"/>
+              <a:defRPr sz="1500" b="1">
+                <a:solidFill>
+                  <a:srgbClr val="000000"/>
                 </a:solidFill>
               </a:defRPr>
             </a:pPr>
             <a:r>
-              <a:t>2. Criterio de Núcleo</a:t>
+              <a:t>3. Parámetros Fijados</a:t>
             </a:r>
             <a:br/>
             <a:r>
-              <a:t>(DBSCAN Espacial)</a:t>
-            </a:r>
-          </a:p>
-          <a:p>
-            <a:br/>
-            <a:pPr algn="ctr">
-              <a:defRPr sz="1800" b="1">
-                <a:solidFill>
-                  <a:srgbClr val="0F172A"/>
-                </a:solidFill>
-              </a:defRPr>
-            </a:pPr>
-            <a:r>
-              <a:t>N_ε(p) = { q | d(p, q) ≤ ε }</a:t>
-            </a:r>
-            <a:br/>
-          </a:p>
-          <a:p>
-            <a:pPr>
-              <a:spcAft>
-                <a:spcPts val="400"/>
-              </a:spcAft>
-              <a:defRPr sz="1150">
-                <a:solidFill>
-                  <a:srgbClr val="1E293B"/>
-                </a:solidFill>
-              </a:defRPr>
-            </a:pPr>
-            <a:r>
-              <a:t>• d(p, q) = Distancia Euclídea 2D</a:t>
-            </a:r>
-          </a:p>
-          <a:p>
-            <a:pPr>
-              <a:spcAft>
-                <a:spcPts val="400"/>
-              </a:spcAft>
-              <a:defRPr sz="1150">
-                <a:solidFill>
-                  <a:srgbClr val="1E293B"/>
-                </a:solidFill>
-              </a:defRPr>
-            </a:pPr>
-            <a:r>
-              <a:t>• Punto Núcleo (Core Point):</a:t>
-            </a:r>
-          </a:p>
-          <a:p>
-            <a:pPr>
-              <a:spcAft>
-                <a:spcPts val="400"/>
-              </a:spcAft>
-              <a:defRPr sz="1150">
-                <a:solidFill>
-                  <a:srgbClr val="1E293B"/>
-                </a:solidFill>
-              </a:defRPr>
-            </a:pPr>
-            <a:r>
-              <a:t>•    |N_ε(p)| ≥ min_samples</a:t>
-            </a:r>
-          </a:p>
-          <a:p>
-            <a:pPr>
-              <a:spcAft>
-                <a:spcPts val="400"/>
-              </a:spcAft>
-              <a:defRPr sz="1150">
-                <a:solidFill>
-                  <a:srgbClr val="1E293B"/>
-                </a:solidFill>
-              </a:defRPr>
-            </a:pPr>
-            <a:r>
-              <a:t>• Punto Frontera (Border):</a:t>
-            </a:r>
-          </a:p>
-          <a:p>
-            <a:pPr>
-              <a:spcAft>
-                <a:spcPts val="400"/>
-              </a:spcAft>
-              <a:defRPr sz="1150">
-                <a:solidFill>
-                  <a:srgbClr val="1E293B"/>
-                </a:solidFill>
-              </a:defRPr>
-            </a:pPr>
-            <a:r>
-              <a:t>•    Alcanzable desde un núcleo</a:t>
-            </a:r>
-          </a:p>
-          <a:p>
-            <a:pPr>
-              <a:spcAft>
-                <a:spcPts val="400"/>
-              </a:spcAft>
-              <a:defRPr sz="1150">
-                <a:solidFill>
-                  <a:srgbClr val="1E293B"/>
-                </a:solidFill>
-              </a:defRPr>
-            </a:pPr>
-            <a:r>
-              <a:t>• Ruido (Noise):</a:t>
-            </a:r>
-          </a:p>
-          <a:p>
-            <a:pPr>
-              <a:spcAft>
-                <a:spcPts val="400"/>
-              </a:spcAft>
-              <a:defRPr sz="1150">
-                <a:solidFill>
-                  <a:srgbClr val="1E293B"/>
-                </a:solidFill>
-              </a:defRPr>
-            </a:pPr>
-            <a:r>
-              <a:t>•    No alcanzable (|N_ε| &lt; min_samples)</a:t>
-            </a:r>
-          </a:p>
-        </p:txBody>
-      </p:sp>
-      <p:sp>
-        <p:nvSpPr>
-          <p:cNvPr id="9" name="Rounded Rectangle 8"/>
-          <p:cNvSpPr/>
+              <a:t>(Criterio Objetivo)</a:t>
+            </a:r>
+          </a:p>
+        </p:txBody>
+      </p:sp>
+      <p:pic>
+        <p:nvPicPr>
+          <p:cNvPr id="14" name="Picture 13" descr="formula_parametros.png"/>
+          <p:cNvPicPr>
+            <a:picLocks noChangeAspect="1"/>
+          </p:cNvPicPr>
           <p:nvPr/>
-        </p:nvSpPr>
-        <p:spPr>
-          <a:xfrm>
-            <a:off x="8138160" y="1554480"/>
-            <a:ext cx="3337560" cy="4572000"/>
-          </a:xfrm>
-          <a:prstGeom prst="roundRect">
+        </p:nvPicPr>
+        <p:blipFill>
+          <a:blip r:embed="rId4"/>
+          <a:stretch>
+            <a:fillRect/>
+          </a:stretch>
+        </p:blipFill>
+        <p:spPr>
+          <a:xfrm>
+            <a:off x="8275320" y="2331720"/>
+            <a:ext cx="3063240" cy="521778"/>
+          </a:xfrm>
+          <a:prstGeom prst="rect">
             <a:avLst/>
           </a:prstGeom>
-          <a:solidFill>
-            <a:srgbClr val="F8FAFC"/>
-          </a:solidFill>
-          <a:ln w="13970">
-            <a:solidFill>
-              <a:srgbClr val="D97706"/>
-            </a:solidFill>
-          </a:ln>
-        </p:spPr>
-        <p:style>
-          <a:lnRef idx="1">
-            <a:schemeClr val="accent1"/>
-          </a:lnRef>
-          <a:fillRef idx="3">
-            <a:schemeClr val="accent1"/>
-          </a:fillRef>
-          <a:effectRef idx="2">
-            <a:schemeClr val="accent1"/>
-          </a:effectRef>
-          <a:fontRef idx="minor">
-            <a:schemeClr val="lt1"/>
-          </a:fontRef>
-        </p:style>
-        <p:txBody>
-          <a:bodyPr rtlCol="0" anchor="ctr"/>
-          <a:lstStyle/>
-          <a:p>
-            <a:pPr algn="ctr"/>
-          </a:p>
-        </p:txBody>
-      </p:sp>
-      <p:sp>
-        <p:nvSpPr>
-          <p:cNvPr id="10" name="TextBox 9"/>
+        </p:spPr>
+      </p:pic>
+      <p:sp>
+        <p:nvSpPr>
+          <p:cNvPr id="15" name="TextBox 14"/>
           <p:cNvSpPr txBox="1"/>
           <p:nvPr/>
         </p:nvSpPr>
         <p:spPr>
           <a:xfrm>
-            <a:off x="8321040" y="1737360"/>
-            <a:ext cx="2971800" cy="4114800"/>
+            <a:off x="8321040" y="3703320"/>
+            <a:ext cx="2971800" cy="2468880"/>
           </a:xfrm>
           <a:prstGeom prst="rect">
             <a:avLst/>
@@ -5833,121 +5843,87 @@
           <a:lstStyle/>
           <a:p>
             <a:pPr>
-              <a:defRPr sz="1600" b="1">
-                <a:solidFill>
-                  <a:srgbClr val="D97706"/>
+              <a:spcAft>
+                <a:spcPts val="500"/>
+              </a:spcAft>
+              <a:defRPr sz="1100">
+                <a:solidFill>
+                  <a:srgbClr val="000000"/>
                 </a:solidFill>
               </a:defRPr>
             </a:pPr>
             <a:r>
-              <a:t>3. Parámetros Fijados</a:t>
-            </a:r>
-            <a:br/>
-            <a:r>
-              <a:t>(Criterio Objetivo)</a:t>
-            </a:r>
-          </a:p>
-          <a:p>
-            <a:br/>
-            <a:pPr algn="ctr">
-              <a:defRPr sz="2000" b="1">
-                <a:solidFill>
-                  <a:srgbClr val="0F172A"/>
-                </a:solidFill>
-              </a:defRPr>
-            </a:pPr>
-            <a:r>
-              <a:t>ε = 0.65</a:t>
-            </a:r>
-            <a:br/>
-            <a:r>
-              <a:t>min_samples = 3</a:t>
-            </a:r>
-            <a:br/>
+              <a:t>• min_samples = 3:</a:t>
+            </a:r>
           </a:p>
           <a:p>
             <a:pPr>
               <a:spcAft>
-                <a:spcPts val="600"/>
+                <a:spcPts val="500"/>
               </a:spcAft>
-              <a:defRPr sz="1150">
-                <a:solidFill>
-                  <a:srgbClr val="1E293B"/>
+              <a:defRPr sz="1100">
+                <a:solidFill>
+                  <a:srgbClr val="000000"/>
                 </a:solidFill>
               </a:defRPr>
             </a:pPr>
             <a:r>
-              <a:t>• min_samples = 3:</a:t>
+              <a:t>•    Regla canónica k ≥ d + 1 (dimensión d = 2).</a:t>
             </a:r>
           </a:p>
           <a:p>
             <a:pPr>
               <a:spcAft>
-                <a:spcPts val="600"/>
+                <a:spcPts val="500"/>
               </a:spcAft>
-              <a:defRPr sz="1150">
-                <a:solidFill>
-                  <a:srgbClr val="1E293B"/>
+              <a:defRPr sz="1100">
+                <a:solidFill>
+                  <a:srgbClr val="000000"/>
                 </a:solidFill>
               </a:defRPr>
             </a:pPr>
             <a:r>
-              <a:t>•    Regla canónica k ≥ d + 1 (dimensión d = 2).</a:t>
+              <a:t>• ε = 0.65:</a:t>
             </a:r>
           </a:p>
           <a:p>
             <a:pPr>
               <a:spcAft>
-                <a:spcPts val="600"/>
+                <a:spcPts val="500"/>
               </a:spcAft>
-              <a:defRPr sz="1150">
-                <a:solidFill>
-                  <a:srgbClr val="1E293B"/>
+              <a:defRPr sz="1100">
+                <a:solidFill>
+                  <a:srgbClr val="000000"/>
                 </a:solidFill>
               </a:defRPr>
             </a:pPr>
             <a:r>
-              <a:t>• ε = 0.65:</a:t>
+              <a:t>•    Determinado mediante gráfico k-NN (codo).</a:t>
             </a:r>
           </a:p>
           <a:p>
             <a:pPr>
               <a:spcAft>
-                <a:spcPts val="600"/>
+                <a:spcPts val="500"/>
               </a:spcAft>
-              <a:defRPr sz="1150">
-                <a:solidFill>
-                  <a:srgbClr val="1E293B"/>
+              <a:defRPr sz="1100">
+                <a:solidFill>
+                  <a:srgbClr val="000000"/>
                 </a:solidFill>
               </a:defRPr>
             </a:pPr>
             <a:r>
-              <a:t>•    Determinado mediante gráfico k-NN (codo).</a:t>
+              <a:t>•    Ventana óptima que aísla aislantes sin fusionar metales.</a:t>
             </a:r>
           </a:p>
           <a:p>
             <a:pPr>
               <a:spcAft>
-                <a:spcPts val="600"/>
+                <a:spcPts val="500"/>
               </a:spcAft>
-              <a:defRPr sz="1150">
-                <a:solidFill>
-                  <a:srgbClr val="1E293B"/>
-                </a:solidFill>
-              </a:defRPr>
-            </a:pPr>
-            <a:r>
-              <a:t>•    Ventana óptima que aísla aislantes sin fusionar metales.</a:t>
-            </a:r>
-          </a:p>
-          <a:p>
-            <a:pPr>
-              <a:spcAft>
-                <a:spcPts val="600"/>
-              </a:spcAft>
-              <a:defRPr sz="1150">
-                <a:solidFill>
-                  <a:srgbClr val="1E293B"/>
+              <a:defRPr sz="1100">
+                <a:solidFill>
+                  <a:srgbClr val="000000"/>
                 </a:solidFill>
               </a:defRPr>
             </a:pPr>
@@ -6000,7 +5976,7 @@
             <a:pPr>
               <a:defRPr sz="2200" b="1">
                 <a:solidFill>
-                  <a:srgbClr val="0F172A"/>
+                  <a:srgbClr val="000000"/>
                 </a:solidFill>
               </a:defRPr>
             </a:pPr>
@@ -6012,7 +5988,7 @@
             <a:pPr>
               <a:defRPr sz="1300">
                 <a:solidFill>
-                  <a:srgbClr val="64748B"/>
+                  <a:srgbClr val="000000"/>
                 </a:solidFill>
               </a:defRPr>
             </a:pPr>
@@ -6072,7 +6048,7 @@
         </p:nvSpPr>
         <p:spPr>
           <a:xfrm>
-            <a:off x="731520" y="320040"/>
+            <a:off x="731520" y="365760"/>
             <a:ext cx="10698480" cy="320040"/>
           </a:xfrm>
           <a:prstGeom prst="rect">
@@ -6089,12 +6065,12 @@
             <a:pPr>
               <a:defRPr sz="1050" b="1">
                 <a:solidFill>
-                  <a:srgbClr val="059669"/>
+                  <a:srgbClr val="000000"/>
                 </a:solidFill>
               </a:defRPr>
             </a:pPr>
             <a:r>
-              <a:t>CPIA · CLUSTERING EN FÍSICA</a:t>
+              <a:t>CPIA · APRENDIZAJE NO SUPERVISADO</a:t>
             </a:r>
           </a:p>
         </p:txBody>
@@ -6107,7 +6083,7 @@
         </p:nvSpPr>
         <p:spPr>
           <a:xfrm>
-            <a:off x="731520" y="621792"/>
+            <a:off x="731520" y="685800"/>
             <a:ext cx="10698480" cy="640080"/>
           </a:xfrm>
           <a:prstGeom prst="rect">
@@ -6122,9 +6098,9 @@
           <a:lstStyle/>
           <a:p>
             <a:pPr>
-              <a:defRPr sz="2200" b="1">
-                <a:solidFill>
-                  <a:srgbClr val="0F172A"/>
+              <a:defRPr sz="2300" b="1">
+                <a:solidFill>
+                  <a:srgbClr val="000000"/>
                 </a:solidFill>
               </a:defRPr>
             </a:pPr>
@@ -6136,24 +6112,24 @@
       </p:sp>
       <p:sp>
         <p:nvSpPr>
-          <p:cNvPr id="4" name="Rectangle 3"/>
+          <p:cNvPr id="4" name="Rounded Rectangle 3"/>
           <p:cNvSpPr/>
           <p:nvPr/>
         </p:nvSpPr>
         <p:spPr>
           <a:xfrm>
-            <a:off x="731520" y="1298448"/>
-            <a:ext cx="10728655" cy="18288"/>
-          </a:xfrm>
-          <a:prstGeom prst="rect">
+            <a:off x="731520" y="1463040"/>
+            <a:ext cx="3337560" cy="3108960"/>
+          </a:xfrm>
+          <a:prstGeom prst="roundRect">
             <a:avLst/>
           </a:prstGeom>
           <a:solidFill>
-            <a:srgbClr val="CBD5E1"/>
+            <a:srgbClr val="FFFFFF"/>
           </a:solidFill>
-          <a:ln>
+          <a:ln w="19050">
             <a:solidFill>
-              <a:srgbClr val="CBD5E1"/>
+              <a:srgbClr val="000000"/>
             </a:solidFill>
           </a:ln>
         </p:spPr>
@@ -6181,24 +6157,96 @@
       </p:sp>
       <p:sp>
         <p:nvSpPr>
-          <p:cNvPr id="5" name="Rounded Rectangle 4"/>
+          <p:cNvPr id="5" name="TextBox 4"/>
+          <p:cNvSpPr txBox="1"/>
+          <p:nvPr/>
+        </p:nvSpPr>
+        <p:spPr>
+          <a:xfrm>
+            <a:off x="914400" y="1645920"/>
+            <a:ext cx="2971800" cy="2743200"/>
+          </a:xfrm>
+          <a:prstGeom prst="rect">
+            <a:avLst/>
+          </a:prstGeom>
+          <a:noFill/>
+        </p:spPr>
+        <p:txBody>
+          <a:bodyPr wrap="square">
+            <a:spAutoFit/>
+          </a:bodyPr>
+          <a:lstStyle/>
+          <a:p>
+            <a:pPr>
+              <a:defRPr sz="1600" b="1">
+                <a:solidFill>
+                  <a:srgbClr val="000000"/>
+                </a:solidFill>
+              </a:defRPr>
+            </a:pPr>
+            <a:r>
+              <a:t>Conductores (Metales)</a:t>
+            </a:r>
+          </a:p>
+          <a:p>
+            <a:pPr algn="ctr">
+              <a:defRPr sz="3200" b="1">
+                <a:solidFill>
+                  <a:srgbClr val="000000"/>
+                </a:solidFill>
+              </a:defRPr>
+            </a:pPr>
+            <a:r>
+              <a:t>35 / 35</a:t>
+            </a:r>
+          </a:p>
+          <a:p>
+            <a:pPr algn="ctr">
+              <a:defRPr sz="1600" b="1">
+                <a:solidFill>
+                  <a:srgbClr val="000000"/>
+                </a:solidFill>
+              </a:defRPr>
+            </a:pPr>
+            <a:r>
+              <a:t>100 % Pureza</a:t>
+            </a:r>
+          </a:p>
+          <a:p>
+            <a:br/>
+            <a:pPr>
+              <a:defRPr sz="1100">
+                <a:solidFill>
+                  <a:srgbClr val="000000"/>
+                </a:solidFill>
+              </a:defRPr>
+            </a:pPr>
+            <a:r>
+              <a:t>Asignados íntegramente al Cluster 0. Cero falsos negativos.</a:t>
+            </a:r>
+          </a:p>
+        </p:txBody>
+      </p:sp>
+      <p:sp>
+        <p:nvSpPr>
+          <p:cNvPr id="6" name="Rounded Rectangle 5"/>
           <p:cNvSpPr/>
           <p:nvPr/>
         </p:nvSpPr>
         <p:spPr>
           <a:xfrm>
-            <a:off x="731520" y="1554480"/>
+            <a:off x="4434840" y="1463040"/>
             <a:ext cx="3337560" cy="3108960"/>
           </a:xfrm>
           <a:prstGeom prst="roundRect">
             <a:avLst/>
           </a:prstGeom>
           <a:solidFill>
-            <a:srgbClr val="F8FAFC"/>
+            <a:srgbClr val="FFFFFF"/>
           </a:solidFill>
-          <a:ln w="13970">
+          <a:ln w="19050">
             <a:solidFill>
-              <a:srgbClr val="D97706"/>
+              <a:srgbClr val="000000"/>
             </a:solidFill>
           </a:ln>
         </p:spPr>
@@ -6226,13 +6274,13 @@
       </p:sp>
       <p:sp>
         <p:nvSpPr>
-          <p:cNvPr id="6" name="TextBox 5"/>
+          <p:cNvPr id="7" name="TextBox 6"/>
           <p:cNvSpPr txBox="1"/>
           <p:nvPr/>
         </p:nvSpPr>
         <p:spPr>
           <a:xfrm>
-            <a:off x="914400" y="1737360"/>
+            <a:off x="4617720" y="1645920"/>
             <a:ext cx="2971800" cy="2743200"/>
           </a:xfrm>
           <a:prstGeom prst="rect">
@@ -6249,31 +6297,31 @@
             <a:pPr>
               <a:defRPr sz="1600" b="1">
                 <a:solidFill>
-                  <a:srgbClr val="D97706"/>
+                  <a:srgbClr val="000000"/>
                 </a:solidFill>
               </a:defRPr>
             </a:pPr>
             <a:r>
-              <a:t>Conductores (Metales)</a:t>
+              <a:t>Aislantes (Dieléctricos)</a:t>
             </a:r>
           </a:p>
           <a:p>
             <a:pPr algn="ctr">
               <a:defRPr sz="3200" b="1">
                 <a:solidFill>
-                  <a:srgbClr val="0F172A"/>
+                  <a:srgbClr val="000000"/>
                 </a:solidFill>
               </a:defRPr>
             </a:pPr>
             <a:r>
-              <a:t>35 / 35</a:t>
+              <a:t>10 / 10</a:t>
             </a:r>
           </a:p>
           <a:p>
             <a:pPr algn="ctr">
               <a:defRPr sz="1600" b="1">
                 <a:solidFill>
-                  <a:srgbClr val="059669"/>
+                  <a:srgbClr val="000000"/>
                 </a:solidFill>
               </a:defRPr>
             </a:pPr>
@@ -6286,36 +6334,36 @@
             <a:pPr>
               <a:defRPr sz="1100">
                 <a:solidFill>
-                  <a:srgbClr val="1E293B"/>
+                  <a:srgbClr val="000000"/>
                 </a:solidFill>
               </a:defRPr>
             </a:pPr>
             <a:r>
-              <a:t>Asignados íntegramente al Cluster 0. Cero falsos negativos.</a:t>
-            </a:r>
-          </a:p>
-        </p:txBody>
-      </p:sp>
-      <p:sp>
-        <p:nvSpPr>
-          <p:cNvPr id="7" name="Rounded Rectangle 6"/>
+              <a:t>Asignados íntegramente al Cluster 1. Coincidencia total con física.</a:t>
+            </a:r>
+          </a:p>
+        </p:txBody>
+      </p:sp>
+      <p:sp>
+        <p:nvSpPr>
+          <p:cNvPr id="8" name="Rounded Rectangle 7"/>
           <p:cNvSpPr/>
           <p:nvPr/>
         </p:nvSpPr>
         <p:spPr>
           <a:xfrm>
-            <a:off x="4434840" y="1554480"/>
+            <a:off x="8138160" y="1463040"/>
             <a:ext cx="3337560" cy="3108960"/>
           </a:xfrm>
           <a:prstGeom prst="roundRect">
             <a:avLst/>
           </a:prstGeom>
           <a:solidFill>
-            <a:srgbClr val="F8FAFC"/>
+            <a:srgbClr val="FFFFFF"/>
           </a:solidFill>
-          <a:ln w="13970">
+          <a:ln w="19050">
             <a:solidFill>
-              <a:srgbClr val="2563EB"/>
+              <a:srgbClr val="000000"/>
             </a:solidFill>
           </a:ln>
         </p:spPr>
@@ -6343,13 +6391,13 @@
       </p:sp>
       <p:sp>
         <p:nvSpPr>
-          <p:cNvPr id="8" name="TextBox 7"/>
+          <p:cNvPr id="9" name="TextBox 8"/>
           <p:cNvSpPr txBox="1"/>
           <p:nvPr/>
         </p:nvSpPr>
         <p:spPr>
           <a:xfrm>
-            <a:off x="4617720" y="1737360"/>
+            <a:off x="8321040" y="1645920"/>
             <a:ext cx="2971800" cy="2743200"/>
           </a:xfrm>
           <a:prstGeom prst="rect">
@@ -6366,73 +6414,73 @@
             <a:pPr>
               <a:defRPr sz="1600" b="1">
                 <a:solidFill>
-                  <a:srgbClr val="2563EB"/>
+                  <a:srgbClr val="000000"/>
                 </a:solidFill>
               </a:defRPr>
             </a:pPr>
             <a:r>
-              <a:t>Aislantes (Dieléctricos)</a:t>
+              <a:t>Semiconductores</a:t>
             </a:r>
           </a:p>
           <a:p>
             <a:pPr algn="ctr">
               <a:defRPr sz="3200" b="1">
                 <a:solidFill>
-                  <a:srgbClr val="0F172A"/>
+                  <a:srgbClr val="000000"/>
                 </a:solidFill>
               </a:defRPr>
             </a:pPr>
             <a:r>
-              <a:t>10 / 10</a:t>
+              <a:t>10 / 12</a:t>
             </a:r>
           </a:p>
           <a:p>
             <a:pPr algn="ctr">
               <a:defRPr sz="1600" b="1">
                 <a:solidFill>
-                  <a:srgbClr val="059669"/>
+                  <a:srgbClr val="000000"/>
                 </a:solidFill>
               </a:defRPr>
             </a:pPr>
             <a:r>
-              <a:t>100 % Pureza</a:t>
+              <a:t>83.3 % Pureza</a:t>
             </a:r>
           </a:p>
           <a:p>
             <a:br/>
             <a:pPr>
-              <a:defRPr sz="1100">
-                <a:solidFill>
-                  <a:srgbClr val="1E293B"/>
+              <a:defRPr sz="1050">
+                <a:solidFill>
+                  <a:srgbClr val="000000"/>
                 </a:solidFill>
               </a:defRPr>
             </a:pPr>
             <a:r>
-              <a:t>Asignados íntegramente al Cluster 1. Coincidencia total con física.</a:t>
-            </a:r>
-          </a:p>
-        </p:txBody>
-      </p:sp>
-      <p:sp>
-        <p:nvSpPr>
-          <p:cNvPr id="9" name="Rounded Rectangle 8"/>
+              <a:t>10 al Cluster 2. 2 semimetales clasificados en cluster 0 por conducción cuasi-metálica.</a:t>
+            </a:r>
+          </a:p>
+        </p:txBody>
+      </p:sp>
+      <p:sp>
+        <p:nvSpPr>
+          <p:cNvPr id="10" name="Rounded Rectangle 9"/>
           <p:cNvSpPr/>
           <p:nvPr/>
         </p:nvSpPr>
         <p:spPr>
           <a:xfrm>
-            <a:off x="8138160" y="1554480"/>
-            <a:ext cx="3337560" cy="3108960"/>
+            <a:off x="731520" y="4800600"/>
+            <a:ext cx="10728655" cy="1417320"/>
           </a:xfrm>
           <a:prstGeom prst="roundRect">
             <a:avLst/>
           </a:prstGeom>
           <a:solidFill>
-            <a:srgbClr val="F8FAFC"/>
+            <a:srgbClr val="FFFFFF"/>
           </a:solidFill>
-          <a:ln w="13970">
+          <a:ln w="19050">
             <a:solidFill>
-              <a:srgbClr val="059669"/>
+              <a:srgbClr val="000000"/>
             </a:solidFill>
           </a:ln>
         </p:spPr>
@@ -6460,14 +6508,14 @@
       </p:sp>
       <p:sp>
         <p:nvSpPr>
-          <p:cNvPr id="10" name="TextBox 9"/>
+          <p:cNvPr id="11" name="TextBox 10"/>
           <p:cNvSpPr txBox="1"/>
           <p:nvPr/>
         </p:nvSpPr>
         <p:spPr>
           <a:xfrm>
-            <a:off x="8321040" y="1737360"/>
-            <a:ext cx="2971800" cy="2743200"/>
+            <a:off x="1005840" y="4892040"/>
+            <a:ext cx="10149840" cy="320040"/>
           </a:xfrm>
           <a:prstGeom prst="rect">
             <a:avLst/>
@@ -6475,156 +6523,48 @@
           <a:noFill/>
         </p:spPr>
         <p:txBody>
-          <a:bodyPr wrap="square">
+          <a:bodyPr wrap="none">
             <a:spAutoFit/>
           </a:bodyPr>
           <a:lstStyle/>
           <a:p>
             <a:pPr>
-              <a:defRPr sz="1600" b="1">
-                <a:solidFill>
-                  <a:srgbClr val="059669"/>
+              <a:defRPr sz="1150" b="1">
+                <a:solidFill>
+                  <a:srgbClr val="000000"/>
                 </a:solidFill>
               </a:defRPr>
             </a:pPr>
             <a:r>
-              <a:t>Semiconductores</a:t>
-            </a:r>
-          </a:p>
-          <a:p>
-            <a:pPr algn="ctr">
-              <a:defRPr sz="3200" b="1">
-                <a:solidFill>
-                  <a:srgbClr val="0F172A"/>
-                </a:solidFill>
-              </a:defRPr>
-            </a:pPr>
-            <a:r>
-              <a:t>10 / 12</a:t>
-            </a:r>
-          </a:p>
-          <a:p>
-            <a:pPr algn="ctr">
-              <a:defRPr sz="1600" b="1">
-                <a:solidFill>
-                  <a:srgbClr val="059669"/>
-                </a:solidFill>
-              </a:defRPr>
-            </a:pPr>
-            <a:r>
-              <a:t>83.3 % Pureza</a:t>
-            </a:r>
-          </a:p>
-          <a:p>
-            <a:br/>
-            <a:pPr>
-              <a:defRPr sz="1050">
-                <a:solidFill>
-                  <a:srgbClr val="1E293B"/>
-                </a:solidFill>
-              </a:defRPr>
-            </a:pPr>
-            <a:r>
-              <a:t>10 al Cluster 2. 2 semimetales clasificados en cluster 0 por conducción cuasi-metálica.</a:t>
-            </a:r>
-          </a:p>
-        </p:txBody>
-      </p:sp>
-      <p:sp>
-        <p:nvSpPr>
-          <p:cNvPr id="11" name="Rounded Rectangle 10"/>
-          <p:cNvSpPr/>
+              <a:t>Métrica Matemática Complementaria (No Supervisada):</a:t>
+            </a:r>
+          </a:p>
+        </p:txBody>
+      </p:sp>
+      <p:pic>
+        <p:nvPicPr>
+          <p:cNvPr id="12" name="Picture 11" descr="formula_silhouette.png"/>
+          <p:cNvPicPr>
+            <a:picLocks noChangeAspect="1"/>
+          </p:cNvPicPr>
           <p:nvPr/>
-        </p:nvSpPr>
-        <p:spPr>
-          <a:xfrm>
-            <a:off x="731520" y="4892040"/>
-            <a:ext cx="10728655" cy="1325880"/>
-          </a:xfrm>
-          <a:prstGeom prst="roundRect">
-            <a:avLst/>
-          </a:prstGeom>
-          <a:solidFill>
-            <a:srgbClr val="F8FAFC"/>
-          </a:solidFill>
-          <a:ln w="13970">
-            <a:solidFill>
-              <a:srgbClr val="CBD5E1"/>
-            </a:solidFill>
-          </a:ln>
-        </p:spPr>
-        <p:style>
-          <a:lnRef idx="1">
-            <a:schemeClr val="accent1"/>
-          </a:lnRef>
-          <a:fillRef idx="3">
-            <a:schemeClr val="accent1"/>
-          </a:fillRef>
-          <a:effectRef idx="2">
-            <a:schemeClr val="accent1"/>
-          </a:effectRef>
-          <a:fontRef idx="minor">
-            <a:schemeClr val="lt1"/>
-          </a:fontRef>
-        </p:style>
-        <p:txBody>
-          <a:bodyPr rtlCol="0" anchor="ctr"/>
-          <a:lstStyle/>
-          <a:p>
-            <a:pPr algn="ctr"/>
-          </a:p>
-        </p:txBody>
-      </p:sp>
-      <p:sp>
-        <p:nvSpPr>
-          <p:cNvPr id="12" name="TextBox 11"/>
-          <p:cNvSpPr txBox="1"/>
-          <p:nvPr/>
-        </p:nvSpPr>
-        <p:spPr>
-          <a:xfrm>
-            <a:off x="1005840" y="4983480"/>
-            <a:ext cx="10149840" cy="1097280"/>
+        </p:nvPicPr>
+        <p:blipFill>
+          <a:blip r:embed="rId2"/>
+          <a:stretch>
+            <a:fillRect/>
+          </a:stretch>
+        </p:blipFill>
+        <p:spPr>
+          <a:xfrm>
+            <a:off x="2011680" y="5257800"/>
+            <a:ext cx="8046720" cy="1356845"/>
           </a:xfrm>
           <a:prstGeom prst="rect">
             <a:avLst/>
           </a:prstGeom>
-          <a:noFill/>
-        </p:spPr>
-        <p:txBody>
-          <a:bodyPr wrap="square">
-            <a:spAutoFit/>
-          </a:bodyPr>
-          <a:lstStyle/>
-          <a:p>
-            <a:pPr>
-              <a:defRPr sz="1200" b="1">
-                <a:solidFill>
-                  <a:srgbClr val="64748B"/>
-                </a:solidFill>
-              </a:defRPr>
-            </a:pPr>
-            <a:r>
-              <a:t>Métrica Matemática Complementaria (No Supervisada):</a:t>
-            </a:r>
-          </a:p>
-          <a:p>
-            <a:pPr>
-              <a:spcBef>
-                <a:spcPts val="400"/>
-              </a:spcBef>
-              <a:defRPr sz="1600" b="1">
-                <a:solidFill>
-                  <a:srgbClr val="059669"/>
-                </a:solidFill>
-              </a:defRPr>
-            </a:pPr>
-            <a:r>
-              <a:t>Silhouette Score = 0.7858   (Excelente separación y cohesión espacial según scikit-learn)</a:t>
-            </a:r>
-          </a:p>
-        </p:txBody>
-      </p:sp>
+        </p:spPr>
+      </p:pic>
     </p:spTree>
   </p:cSld>
   <p:clrMapOvr>
@@ -6651,7 +6591,7 @@
         </p:nvSpPr>
         <p:spPr>
           <a:xfrm>
-            <a:off x="731520" y="320040"/>
+            <a:off x="731520" y="365760"/>
             <a:ext cx="10698480" cy="320040"/>
           </a:xfrm>
           <a:prstGeom prst="rect">
@@ -6668,12 +6608,12 @@
             <a:pPr>
               <a:defRPr sz="1050" b="1">
                 <a:solidFill>
-                  <a:srgbClr val="059669"/>
+                  <a:srgbClr val="000000"/>
                 </a:solidFill>
               </a:defRPr>
             </a:pPr>
             <a:r>
-              <a:t>CPIA · CLUSTERING EN FÍSICA</a:t>
+              <a:t>CPIA · APRENDIZAJE NO SUPERVISADO</a:t>
             </a:r>
           </a:p>
         </p:txBody>
@@ -6686,7 +6626,7 @@
         </p:nvSpPr>
         <p:spPr>
           <a:xfrm>
-            <a:off x="731520" y="621792"/>
+            <a:off x="731520" y="685800"/>
             <a:ext cx="10698480" cy="640080"/>
           </a:xfrm>
           <a:prstGeom prst="rect">
@@ -6701,9 +6641,9 @@
           <a:lstStyle/>
           <a:p>
             <a:pPr>
-              <a:defRPr sz="2200" b="1">
-                <a:solidFill>
-                  <a:srgbClr val="0F172A"/>
+              <a:defRPr sz="2300" b="1">
+                <a:solidFill>
+                  <a:srgbClr val="000000"/>
                 </a:solidFill>
               </a:defRPr>
             </a:pPr>
@@ -6715,24 +6655,24 @@
       </p:sp>
       <p:sp>
         <p:nvSpPr>
-          <p:cNvPr id="4" name="Rectangle 3"/>
+          <p:cNvPr id="4" name="Rounded Rectangle 3"/>
           <p:cNvSpPr/>
           <p:nvPr/>
         </p:nvSpPr>
         <p:spPr>
           <a:xfrm>
-            <a:off x="731520" y="1298448"/>
-            <a:ext cx="10728655" cy="18288"/>
-          </a:xfrm>
-          <a:prstGeom prst="rect">
+            <a:off x="1097280" y="1554480"/>
+            <a:ext cx="9997135" cy="4572000"/>
+          </a:xfrm>
+          <a:prstGeom prst="roundRect">
             <a:avLst/>
           </a:prstGeom>
           <a:solidFill>
-            <a:srgbClr val="CBD5E1"/>
+            <a:srgbClr val="FFFFFF"/>
           </a:solidFill>
-          <a:ln>
+          <a:ln w="19050">
             <a:solidFill>
-              <a:srgbClr val="CBD5E1"/>
+              <a:srgbClr val="000000"/>
             </a:solidFill>
           </a:ln>
         </p:spPr>
@@ -6760,59 +6700,14 @@
       </p:sp>
       <p:sp>
         <p:nvSpPr>
-          <p:cNvPr id="5" name="Rounded Rectangle 4"/>
-          <p:cNvSpPr/>
-          <p:nvPr/>
-        </p:nvSpPr>
-        <p:spPr>
-          <a:xfrm>
-            <a:off x="1097280" y="1645920"/>
-            <a:ext cx="9997135" cy="4480560"/>
-          </a:xfrm>
-          <a:prstGeom prst="roundRect">
-            <a:avLst/>
-          </a:prstGeom>
-          <a:solidFill>
-            <a:srgbClr val="F8FAFC"/>
-          </a:solidFill>
-          <a:ln w="13970">
-            <a:solidFill>
-              <a:srgbClr val="059669"/>
-            </a:solidFill>
-          </a:ln>
-        </p:spPr>
-        <p:style>
-          <a:lnRef idx="1">
-            <a:schemeClr val="accent1"/>
-          </a:lnRef>
-          <a:fillRef idx="3">
-            <a:schemeClr val="accent1"/>
-          </a:fillRef>
-          <a:effectRef idx="2">
-            <a:schemeClr val="accent1"/>
-          </a:effectRef>
-          <a:fontRef idx="minor">
-            <a:schemeClr val="lt1"/>
-          </a:fontRef>
-        </p:style>
-        <p:txBody>
-          <a:bodyPr rtlCol="0" anchor="ctr"/>
-          <a:lstStyle/>
-          <a:p>
-            <a:pPr algn="ctr"/>
-          </a:p>
-        </p:txBody>
-      </p:sp>
-      <p:sp>
-        <p:nvSpPr>
-          <p:cNvPr id="6" name="TextBox 5"/>
+          <p:cNvPr id="5" name="TextBox 4"/>
           <p:cNvSpPr txBox="1"/>
           <p:nvPr/>
         </p:nvSpPr>
         <p:spPr>
           <a:xfrm>
-            <a:off x="1463040" y="1920240"/>
-            <a:ext cx="9235440" cy="3931920"/>
+            <a:off x="1463040" y="1828800"/>
+            <a:ext cx="9235440" cy="4023360"/>
           </a:xfrm>
           <a:prstGeom prst="rect">
             <a:avLst/>
@@ -6831,7 +6726,7 @@
               </a:spcAft>
               <a:defRPr sz="2000" b="1">
                 <a:solidFill>
-                  <a:srgbClr val="0F172A"/>
+                  <a:srgbClr val="000000"/>
                 </a:solidFill>
               </a:defRPr>
             </a:pPr>
@@ -6844,9 +6739,9 @@
               <a:spcAft>
                 <a:spcPts val="1200"/>
               </a:spcAft>
-              <a:defRPr sz="1450">
-                <a:solidFill>
-                  <a:srgbClr val="1E293B"/>
+              <a:defRPr sz="1400">
+                <a:solidFill>
+                  <a:srgbClr val="000000"/>
                 </a:solidFill>
               </a:defRPr>
             </a:pPr>
@@ -6859,9 +6754,9 @@
               <a:spcAft>
                 <a:spcPts val="1200"/>
               </a:spcAft>
-              <a:defRPr sz="1450">
-                <a:solidFill>
-                  <a:srgbClr val="1E293B"/>
+              <a:defRPr sz="1400">
+                <a:solidFill>
+                  <a:srgbClr val="000000"/>
                 </a:solidFill>
               </a:defRPr>
             </a:pPr>
@@ -6874,9 +6769,9 @@
               <a:spcAft>
                 <a:spcPts val="1200"/>
               </a:spcAft>
-              <a:defRPr sz="1450">
-                <a:solidFill>
-                  <a:srgbClr val="1E293B"/>
+              <a:defRPr sz="1400">
+                <a:solidFill>
+                  <a:srgbClr val="000000"/>
                 </a:solidFill>
               </a:defRPr>
             </a:pPr>
@@ -6889,9 +6784,9 @@
               <a:spcAft>
                 <a:spcPts val="1200"/>
               </a:spcAft>
-              <a:defRPr sz="1450">
-                <a:solidFill>
-                  <a:srgbClr val="1E293B"/>
+              <a:defRPr sz="1400">
+                <a:solidFill>
+                  <a:srgbClr val="000000"/>
                 </a:solidFill>
               </a:defRPr>
             </a:pPr>

</xml_diff>

<commit_message>
docs(slides): actualitzar presentacio d'Uriel amb els canvis de disseny i text
</commit_message>
<xml_diff>
--- a/presentacion/presentacion_materiales_uriel.pptx
+++ b/presentacion/presentacion_materiales_uriel.pptx
@@ -764,7 +764,7 @@
           </a:p>
           <a:p>
             <a:r>
-              <a:t>Pregunta clau: per què DBSCAN i no K-Means?</a:t>
+              <a:t>DBSCAN vs. K-Means:</a:t>
             </a:r>
           </a:p>
           <a:p>
@@ -1054,12 +1054,7 @@
           </a:p>
           <a:p>
             <a:r>
-              <a:t>- En semiconductors, els 10 materials tecnològics purs formen el clúster 2. Els dos restants són semimetalls amb transport cuasimetàl·lic a 300 K.</a:t>
-            </a:r>
-          </a:p>
-          <a:p>
-            <a:r>
-              <a:t>I com a mètrica matemàtica complementària, la fórmula de Silhouette Score dona 0.7858.</a:t>
+              <a:t>- En semiconductors, 10 de 12 materials purs formen el clúster 2. Els dos restants són semimetalls amb transport cuasimetàl·lic a 300 K.</a:t>
             </a:r>
           </a:p>
         </p:txBody>
@@ -4321,7 +4316,7 @@
               <a:rPr>
                 <a:latin typeface="Arial"/>
               </a:rPr>
-              <a:t>Descobriment No Supervisat de Fases Quàntiques (Conductors, Semiconductors i Aïllants)</a:t>
+              <a:t>Classificació de materials Conductors, Semiconductors i Aïllants</a:t>
             </a:r>
           </a:p>
         </p:txBody>
@@ -4915,7 +4910,7 @@
               <a:rPr>
                 <a:latin typeface="Arial"/>
               </a:rPr>
-              <a:t>• Signatura quàntica: α delata l'origen microscòpic del transport.</a:t>
+              <a:t>• Signatura quàntica: α indica l'origen microscòpic del transport.</a:t>
             </a:r>
           </a:p>
           <a:p>
@@ -5054,7 +5049,7 @@
               <a:rPr>
                 <a:latin typeface="Arial"/>
               </a:rPr>
-              <a:t>Per què DBSCAN i no K-Means?</a:t>
+              <a:t>DBSCAN vs. K-Means?</a:t>
             </a:r>
           </a:p>
         </p:txBody>
@@ -6387,7 +6382,7 @@
         <p:spPr>
           <a:xfrm>
             <a:off x="731520" y="1463040"/>
-            <a:ext cx="3337560" cy="3108960"/>
+            <a:ext cx="3337560" cy="4754880"/>
           </a:xfrm>
           <a:prstGeom prst="roundRect">
             <a:avLst/>
@@ -6435,8 +6430,8 @@
         </p:nvSpPr>
         <p:spPr>
           <a:xfrm>
-            <a:off x="914400" y="1645920"/>
-            <a:ext cx="2971800" cy="2743200"/>
+            <a:off x="914400" y="1783080"/>
+            <a:ext cx="2971800" cy="4114800"/>
           </a:xfrm>
           <a:prstGeom prst="rect">
             <a:avLst/>
@@ -6450,7 +6445,7 @@
           <a:lstStyle/>
           <a:p>
             <a:pPr>
-              <a:defRPr sz="1600" b="1">
+              <a:defRPr sz="1800" b="1">
                 <a:solidFill>
                   <a:srgbClr val="000000"/>
                 </a:solidFill>
@@ -6466,7 +6461,7 @@
           </a:p>
           <a:p>
             <a:pPr algn="ctr">
-              <a:defRPr sz="3200" b="1">
+              <a:defRPr sz="3600" b="1">
                 <a:solidFill>
                   <a:srgbClr val="000000"/>
                 </a:solidFill>
@@ -6482,7 +6477,7 @@
           </a:p>
           <a:p>
             <a:pPr algn="ctr">
-              <a:defRPr sz="1600" b="1">
+              <a:defRPr sz="1800" b="1">
                 <a:solidFill>
                   <a:srgbClr val="000000"/>
                 </a:solidFill>
@@ -6499,7 +6494,7 @@
           <a:p>
             <a:br/>
             <a:pPr>
-              <a:defRPr sz="1100">
+              <a:defRPr sz="1300">
                 <a:solidFill>
                   <a:srgbClr val="000000"/>
                 </a:solidFill>
@@ -6524,7 +6519,7 @@
         <p:spPr>
           <a:xfrm>
             <a:off x="4434840" y="1463040"/>
-            <a:ext cx="3337560" cy="3108960"/>
+            <a:ext cx="3337560" cy="4754880"/>
           </a:xfrm>
           <a:prstGeom prst="roundRect">
             <a:avLst/>
@@ -6572,8 +6567,8 @@
         </p:nvSpPr>
         <p:spPr>
           <a:xfrm>
-            <a:off x="4617720" y="1645920"/>
-            <a:ext cx="2971800" cy="2743200"/>
+            <a:off x="4617720" y="1783080"/>
+            <a:ext cx="2971800" cy="4114800"/>
           </a:xfrm>
           <a:prstGeom prst="rect">
             <a:avLst/>
@@ -6587,7 +6582,7 @@
           <a:lstStyle/>
           <a:p>
             <a:pPr>
-              <a:defRPr sz="1600" b="1">
+              <a:defRPr sz="1800" b="1">
                 <a:solidFill>
                   <a:srgbClr val="000000"/>
                 </a:solidFill>
@@ -6603,7 +6598,7 @@
           </a:p>
           <a:p>
             <a:pPr algn="ctr">
-              <a:defRPr sz="3200" b="1">
+              <a:defRPr sz="3600" b="1">
                 <a:solidFill>
                   <a:srgbClr val="000000"/>
                 </a:solidFill>
@@ -6619,7 +6614,7 @@
           </a:p>
           <a:p>
             <a:pPr algn="ctr">
-              <a:defRPr sz="1600" b="1">
+              <a:defRPr sz="1800" b="1">
                 <a:solidFill>
                   <a:srgbClr val="000000"/>
                 </a:solidFill>
@@ -6636,7 +6631,7 @@
           <a:p>
             <a:br/>
             <a:pPr>
-              <a:defRPr sz="1100">
+              <a:defRPr sz="1300">
                 <a:solidFill>
                   <a:srgbClr val="000000"/>
                 </a:solidFill>
@@ -6661,7 +6656,7 @@
         <p:spPr>
           <a:xfrm>
             <a:off x="8138160" y="1463040"/>
-            <a:ext cx="3337560" cy="3108960"/>
+            <a:ext cx="3337560" cy="4754880"/>
           </a:xfrm>
           <a:prstGeom prst="roundRect">
             <a:avLst/>
@@ -6709,8 +6704,8 @@
         </p:nvSpPr>
         <p:spPr>
           <a:xfrm>
-            <a:off x="8321040" y="1645920"/>
-            <a:ext cx="2971800" cy="2743200"/>
+            <a:off x="8321040" y="1783080"/>
+            <a:ext cx="2971800" cy="4114800"/>
           </a:xfrm>
           <a:prstGeom prst="rect">
             <a:avLst/>
@@ -6724,7 +6719,7 @@
           <a:lstStyle/>
           <a:p>
             <a:pPr>
-              <a:defRPr sz="1600" b="1">
+              <a:defRPr sz="1800" b="1">
                 <a:solidFill>
                   <a:srgbClr val="000000"/>
                 </a:solidFill>
@@ -6740,7 +6735,7 @@
           </a:p>
           <a:p>
             <a:pPr algn="ctr">
-              <a:defRPr sz="3200" b="1">
+              <a:defRPr sz="3600" b="1">
                 <a:solidFill>
                   <a:srgbClr val="000000"/>
                 </a:solidFill>
@@ -6756,7 +6751,7 @@
           </a:p>
           <a:p>
             <a:pPr algn="ctr">
-              <a:defRPr sz="1600" b="1">
+              <a:defRPr sz="1800" b="1">
                 <a:solidFill>
                   <a:srgbClr val="000000"/>
                 </a:solidFill>
@@ -6773,7 +6768,7 @@
           <a:p>
             <a:br/>
             <a:pPr>
-              <a:defRPr sz="1050">
+              <a:defRPr sz="1200">
                 <a:solidFill>
                   <a:srgbClr val="000000"/>
                 </a:solidFill>
@@ -6789,118 +6784,6 @@
           </a:p>
         </p:txBody>
       </p:sp>
-      <p:sp>
-        <p:nvSpPr>
-          <p:cNvPr id="10" name="Rounded Rectangle 9"/>
-          <p:cNvSpPr/>
-          <p:nvPr/>
-        </p:nvSpPr>
-        <p:spPr>
-          <a:xfrm>
-            <a:off x="731520" y="4800600"/>
-            <a:ext cx="10728655" cy="1417320"/>
-          </a:xfrm>
-          <a:prstGeom prst="roundRect">
-            <a:avLst/>
-          </a:prstGeom>
-          <a:solidFill>
-            <a:srgbClr val="FFFFFF"/>
-          </a:solidFill>
-          <a:ln w="19050">
-            <a:solidFill>
-              <a:srgbClr val="000000"/>
-            </a:solidFill>
-          </a:ln>
-        </p:spPr>
-        <p:style>
-          <a:lnRef idx="1">
-            <a:schemeClr val="accent1"/>
-          </a:lnRef>
-          <a:fillRef idx="3">
-            <a:schemeClr val="accent1"/>
-          </a:fillRef>
-          <a:effectRef idx="2">
-            <a:schemeClr val="accent1"/>
-          </a:effectRef>
-          <a:fontRef idx="minor">
-            <a:schemeClr val="lt1"/>
-          </a:fontRef>
-        </p:style>
-        <p:txBody>
-          <a:bodyPr rtlCol="0" anchor="ctr"/>
-          <a:lstStyle/>
-          <a:p>
-            <a:pPr algn="ctr">
-              <a:defRPr>
-                <a:latin typeface="Arial"/>
-              </a:defRPr>
-            </a:pPr>
-          </a:p>
-        </p:txBody>
-      </p:sp>
-      <p:sp>
-        <p:nvSpPr>
-          <p:cNvPr id="11" name="TextBox 10"/>
-          <p:cNvSpPr txBox="1"/>
-          <p:nvPr/>
-        </p:nvSpPr>
-        <p:spPr>
-          <a:xfrm>
-            <a:off x="1005840" y="4892040"/>
-            <a:ext cx="10149840" cy="320040"/>
-          </a:xfrm>
-          <a:prstGeom prst="rect">
-            <a:avLst/>
-          </a:prstGeom>
-          <a:noFill/>
-        </p:spPr>
-        <p:txBody>
-          <a:bodyPr wrap="none">
-            <a:spAutoFit/>
-          </a:bodyPr>
-          <a:lstStyle/>
-          <a:p>
-            <a:pPr>
-              <a:defRPr sz="1150" b="1">
-                <a:solidFill>
-                  <a:srgbClr val="000000"/>
-                </a:solidFill>
-                <a:latin typeface="Arial"/>
-              </a:defRPr>
-            </a:pPr>
-            <a:r>
-              <a:rPr>
-                <a:latin typeface="Arial"/>
-              </a:rPr>
-              <a:t>Mètrica Matemàtica Complementària (No Supervisada):</a:t>
-            </a:r>
-          </a:p>
-        </p:txBody>
-      </p:sp>
-      <p:pic>
-        <p:nvPicPr>
-          <p:cNvPr id="12" name="Picture 11" descr="formula_silhouette.png"/>
-          <p:cNvPicPr>
-            <a:picLocks noChangeAspect="1"/>
-          </p:cNvPicPr>
-          <p:nvPr/>
-        </p:nvPicPr>
-        <p:blipFill>
-          <a:blip r:embed="rId2"/>
-          <a:stretch>
-            <a:fillRect/>
-          </a:stretch>
-        </p:blipFill>
-        <p:spPr>
-          <a:xfrm>
-            <a:off x="2011680" y="5257800"/>
-            <a:ext cx="8046720" cy="1356845"/>
-          </a:xfrm>
-          <a:prstGeom prst="rect">
-            <a:avLst/>
-          </a:prstGeom>
-        </p:spPr>
-      </p:pic>
     </p:spTree>
   </p:cSld>
   <p:clrMapOvr>

</xml_diff>